<commit_message>
Add college logo graphic on Slide 1 details card
</commit_message>
<xml_diff>
--- a/AI_Based_Document_Similarity_Duplicate_Detection_NLP_PBL.pptx
+++ b/AI_Based_Document_Similarity_Duplicate_Detection_NLP_PBL.pptx
@@ -3472,48 +3472,73 @@
       </p:sp>
       <p:sp>
         <p:nvSpPr>
-          <p:cNvPr id="8" name="TextBox 7"/>
-          <p:cNvSpPr txBox="1"/>
+          <p:cNvPr id="8" name="Rounded Rectangle 7"/>
+          <p:cNvSpPr/>
           <p:nvPr/>
         </p:nvSpPr>
         <p:spPr>
           <a:xfrm>
-            <a:off x="1097280" y="4663440"/>
-            <a:ext cx="9966960" cy="548640"/>
+            <a:off x="3346704" y="4663440"/>
+            <a:ext cx="5486400" cy="1188720"/>
+          </a:xfrm>
+          <a:prstGeom prst="roundRect">
+            <a:avLst/>
+          </a:prstGeom>
+          <a:solidFill>
+            <a:srgbClr val="FFFFFF"/>
+          </a:solidFill>
+          <a:ln w="19050">
+            <a:solidFill>
+              <a:srgbClr val="38BDF8"/>
+            </a:solidFill>
+          </a:ln>
+        </p:spPr>
+        <p:style>
+          <a:lnRef idx="1">
+            <a:schemeClr val="accent1"/>
+          </a:lnRef>
+          <a:fillRef idx="3">
+            <a:schemeClr val="accent1"/>
+          </a:fillRef>
+          <a:effectRef idx="2">
+            <a:schemeClr val="accent1"/>
+          </a:effectRef>
+          <a:fontRef idx="minor">
+            <a:schemeClr val="lt1"/>
+          </a:fontRef>
+        </p:style>
+        <p:txBody>
+          <a:bodyPr rtlCol="0" anchor="ctr"/>
+          <a:lstStyle/>
+          <a:p>
+            <a:pPr algn="ctr"/>
+          </a:p>
+        </p:txBody>
+      </p:sp>
+      <p:pic>
+        <p:nvPicPr>
+          <p:cNvPr id="9" name="Picture 8" descr="college_logo.png"/>
+          <p:cNvPicPr>
+            <a:picLocks noChangeAspect="1"/>
+          </p:cNvPicPr>
+          <p:nvPr/>
+        </p:nvPicPr>
+        <p:blipFill>
+          <a:blip r:embed="rId2"/>
+          <a:stretch>
+            <a:fillRect/>
+          </a:stretch>
+        </p:blipFill>
+        <p:spPr>
+          <a:xfrm>
+            <a:off x="3438144" y="4709160"/>
+            <a:ext cx="5303520" cy="1097280"/>
           </a:xfrm>
           <a:prstGeom prst="rect">
             <a:avLst/>
           </a:prstGeom>
-          <a:noFill/>
         </p:spPr>
-        <p:txBody>
-          <a:bodyPr wrap="none">
-            <a:spAutoFit/>
-          </a:bodyPr>
-          <a:lstStyle/>
-          <a:p>
-            <a:pPr algn="ctr"/>
-            <a:r>
-              <a:rPr b="1" sz="1700">
-                <a:solidFill>
-                  <a:srgbClr val="38BDF8"/>
-                </a:solidFill>
-                <a:latin typeface="Segoe UI"/>
-              </a:rPr>
-              <a:t>COLLEGE: </a:t>
-            </a:r>
-            <a:r>
-              <a:rPr sz="1700">
-                <a:solidFill>
-                  <a:srgbClr val="FFFFFF"/>
-                </a:solidFill>
-                <a:latin typeface="Segoe UI"/>
-              </a:rPr>
-              <a:t>B H Gardi College Of Engineering And Technology</a:t>
-            </a:r>
-          </a:p>
-        </p:txBody>
-      </p:sp>
+      </p:pic>
     </p:spTree>
   </p:cSld>
   <p:clrMapOvr>

</xml_diff>

<commit_message>
Switch presentation theme to high-contrast Light Theme for clean college logo rendering
</commit_message>
<xml_diff>
--- a/AI_Based_Document_Similarity_Duplicate_Detection_NLP_PBL.pptx
+++ b/AI_Based_Document_Similarity_Duplicate_Detection_NLP_PBL.pptx
@@ -3115,7 +3115,7 @@
     <p:bg>
       <p:bgPr>
         <a:solidFill>
-          <a:srgbClr val="0F172A"/>
+          <a:srgbClr val="F1F5F9"/>
         </a:solidFill>
         <a:effectLst/>
       </p:bgPr>
@@ -3152,7 +3152,7 @@
             <a:pPr algn="ctr">
               <a:defRPr sz="2800" b="1">
                 <a:solidFill>
-                  <a:srgbClr val="38BDF8"/>
+                  <a:srgbClr val="4F46E5"/>
                 </a:solidFill>
                 <a:latin typeface="Segoe UI"/>
               </a:defRPr>
@@ -3168,7 +3168,7 @@
               </a:spcBef>
               <a:defRPr sz="1600">
                 <a:solidFill>
-                  <a:srgbClr val="94A3B8"/>
+                  <a:srgbClr val="475569"/>
                 </a:solidFill>
                 <a:latin typeface="Segoe UI"/>
               </a:defRPr>
@@ -3209,7 +3209,7 @@
             <a:r>
               <a:rPr sz="1800" b="1">
                 <a:solidFill>
-                  <a:srgbClr val="A3E635"/>
+                  <a:srgbClr val="4F46E5"/>
                 </a:solidFill>
                 <a:latin typeface="Segoe UI"/>
               </a:rPr>
@@ -3218,7 +3218,7 @@
             <a:r>
               <a:rPr sz="1800" b="1">
                 <a:solidFill>
-                  <a:srgbClr val="FFFFFF"/>
+                  <a:srgbClr val="0F172A"/>
                 </a:solidFill>
                 <a:latin typeface="Segoe UI"/>
               </a:rPr>
@@ -3242,7 +3242,7 @@
             <a:avLst/>
           </a:prstGeom>
           <a:solidFill>
-            <a:srgbClr val="1E293B"/>
+            <a:srgbClr val="FFFFFF"/>
           </a:solidFill>
           <a:ln w="19050">
             <a:solidFill>
@@ -3297,7 +3297,7 @@
             <a:r>
               <a:rPr b="1" sz="1700">
                 <a:solidFill>
-                  <a:srgbClr val="38BDF8"/>
+                  <a:srgbClr val="4F46E5"/>
                 </a:solidFill>
                 <a:latin typeface="Segoe UI"/>
               </a:rPr>
@@ -3306,7 +3306,7 @@
             <a:r>
               <a:rPr sz="1700">
                 <a:solidFill>
-                  <a:srgbClr val="FFFFFF"/>
+                  <a:srgbClr val="0F172A"/>
                 </a:solidFill>
                 <a:latin typeface="Segoe UI"/>
               </a:rPr>
@@ -3322,7 +3322,7 @@
             <a:r>
               <a:rPr b="1" sz="1700">
                 <a:solidFill>
-                  <a:srgbClr val="38BDF8"/>
+                  <a:srgbClr val="4F46E5"/>
                 </a:solidFill>
                 <a:latin typeface="Segoe UI"/>
               </a:rPr>
@@ -3331,7 +3331,7 @@
             <a:r>
               <a:rPr sz="1700">
                 <a:solidFill>
-                  <a:srgbClr val="FFFFFF"/>
+                  <a:srgbClr val="0F172A"/>
                 </a:solidFill>
                 <a:latin typeface="Segoe UI"/>
               </a:rPr>
@@ -3365,7 +3365,7 @@
             <a:r>
               <a:rPr b="1" sz="1700">
                 <a:solidFill>
-                  <a:srgbClr val="38BDF8"/>
+                  <a:srgbClr val="4F46E5"/>
                 </a:solidFill>
                 <a:latin typeface="Segoe UI"/>
               </a:rPr>
@@ -3374,7 +3374,7 @@
             <a:r>
               <a:rPr sz="1700">
                 <a:solidFill>
-                  <a:srgbClr val="FFFFFF"/>
+                  <a:srgbClr val="0F172A"/>
                 </a:solidFill>
                 <a:latin typeface="Segoe UI"/>
               </a:rPr>
@@ -3390,7 +3390,7 @@
             <a:r>
               <a:rPr b="1" sz="1700">
                 <a:solidFill>
-                  <a:srgbClr val="38BDF8"/>
+                  <a:srgbClr val="4F46E5"/>
                 </a:solidFill>
                 <a:latin typeface="Segoe UI"/>
               </a:rPr>
@@ -3399,7 +3399,7 @@
             <a:r>
               <a:rPr sz="1700">
                 <a:solidFill>
-                  <a:srgbClr val="FFFFFF"/>
+                  <a:srgbClr val="0F172A"/>
                 </a:solidFill>
                 <a:latin typeface="Segoe UI"/>
               </a:rPr>
@@ -3434,7 +3434,7 @@
             <a:r>
               <a:rPr b="1" sz="1700">
                 <a:solidFill>
-                  <a:srgbClr val="38BDF8"/>
+                  <a:srgbClr val="4F46E5"/>
                 </a:solidFill>
                 <a:latin typeface="Segoe UI"/>
               </a:rPr>
@@ -3443,7 +3443,7 @@
             <a:r>
               <a:rPr sz="1700">
                 <a:solidFill>
-                  <a:srgbClr val="FFFFFF"/>
+                  <a:srgbClr val="0F172A"/>
                 </a:solidFill>
                 <a:latin typeface="Segoe UI"/>
               </a:rPr>
@@ -3452,7 +3452,7 @@
             <a:r>
               <a:rPr b="1" sz="1700">
                 <a:solidFill>
-                  <a:srgbClr val="38BDF8"/>
+                  <a:srgbClr val="4F46E5"/>
                 </a:solidFill>
                 <a:latin typeface="Segoe UI"/>
               </a:rPr>
@@ -3461,63 +3461,18 @@
             <a:r>
               <a:rPr sz="1700">
                 <a:solidFill>
-                  <a:srgbClr val="FFFFFF"/>
+                  <a:srgbClr val="0F172A"/>
                 </a:solidFill>
                 <a:latin typeface="Segoe UI"/>
               </a:rPr>
               <a:t>5th</a:t>
             </a:r>
-          </a:p>
-        </p:txBody>
-      </p:sp>
-      <p:sp>
-        <p:nvSpPr>
-          <p:cNvPr id="8" name="Rounded Rectangle 7"/>
-          <p:cNvSpPr/>
-          <p:nvPr/>
-        </p:nvSpPr>
-        <p:spPr>
-          <a:xfrm>
-            <a:off x="3346704" y="4663440"/>
-            <a:ext cx="5486400" cy="1188720"/>
-          </a:xfrm>
-          <a:prstGeom prst="roundRect">
-            <a:avLst/>
-          </a:prstGeom>
-          <a:solidFill>
-            <a:srgbClr val="FFFFFF"/>
-          </a:solidFill>
-          <a:ln w="19050">
-            <a:solidFill>
-              <a:srgbClr val="38BDF8"/>
-            </a:solidFill>
-          </a:ln>
-        </p:spPr>
-        <p:style>
-          <a:lnRef idx="1">
-            <a:schemeClr val="accent1"/>
-          </a:lnRef>
-          <a:fillRef idx="3">
-            <a:schemeClr val="accent1"/>
-          </a:fillRef>
-          <a:effectRef idx="2">
-            <a:schemeClr val="accent1"/>
-          </a:effectRef>
-          <a:fontRef idx="minor">
-            <a:schemeClr val="lt1"/>
-          </a:fontRef>
-        </p:style>
-        <p:txBody>
-          <a:bodyPr rtlCol="0" anchor="ctr"/>
-          <a:lstStyle/>
-          <a:p>
-            <a:pPr algn="ctr"/>
           </a:p>
         </p:txBody>
       </p:sp>
       <p:pic>
         <p:nvPicPr>
-          <p:cNvPr id="9" name="Picture 8" descr="college_logo.png"/>
+          <p:cNvPr id="8" name="Picture 7" descr="college_logo.png"/>
           <p:cNvPicPr>
             <a:picLocks noChangeAspect="1"/>
           </p:cNvPicPr>
@@ -3531,7 +3486,7 @@
         </p:blipFill>
         <p:spPr>
           <a:xfrm>
-            <a:off x="3438144" y="4709160"/>
+            <a:off x="3438144" y="4663440"/>
             <a:ext cx="5303520" cy="1097280"/>
           </a:xfrm>
           <a:prstGeom prst="rect">
@@ -3553,7 +3508,7 @@
     <p:bg>
       <p:bgPr>
         <a:solidFill>
-          <a:srgbClr val="0F172A"/>
+          <a:srgbClr val="F1F5F9"/>
         </a:solidFill>
         <a:effectLst/>
       </p:bgPr>
@@ -3590,7 +3545,7 @@
             <a:pPr>
               <a:defRPr sz="3200" b="1">
                 <a:solidFill>
-                  <a:srgbClr val="38BDF8"/>
+                  <a:srgbClr val="4F46E5"/>
                 </a:solidFill>
                 <a:latin typeface="Segoe UI"/>
               </a:defRPr>
@@ -3629,7 +3584,7 @@
               </a:spcAft>
               <a:defRPr sz="1600">
                 <a:solidFill>
-                  <a:srgbClr val="94A3B8"/>
+                  <a:srgbClr val="475569"/>
                 </a:solidFill>
                 <a:latin typeface="Segoe UI"/>
               </a:defRPr>
@@ -3645,7 +3600,7 @@
               </a:spcAft>
               <a:defRPr sz="1600">
                 <a:solidFill>
-                  <a:srgbClr val="94A3B8"/>
+                  <a:srgbClr val="475569"/>
                 </a:solidFill>
                 <a:latin typeface="Segoe UI"/>
               </a:defRPr>
@@ -3661,7 +3616,7 @@
               </a:spcAft>
               <a:defRPr sz="1600">
                 <a:solidFill>
-                  <a:srgbClr val="94A3B8"/>
+                  <a:srgbClr val="475569"/>
                 </a:solidFill>
                 <a:latin typeface="Segoe UI"/>
               </a:defRPr>
@@ -3677,7 +3632,7 @@
               </a:spcAft>
               <a:defRPr sz="1600">
                 <a:solidFill>
-                  <a:srgbClr val="94A3B8"/>
+                  <a:srgbClr val="475569"/>
                 </a:solidFill>
                 <a:latin typeface="Segoe UI"/>
               </a:defRPr>
@@ -3693,7 +3648,7 @@
               </a:spcAft>
               <a:defRPr sz="1600">
                 <a:solidFill>
-                  <a:srgbClr val="94A3B8"/>
+                  <a:srgbClr val="475569"/>
                 </a:solidFill>
                 <a:latin typeface="Segoe UI"/>
               </a:defRPr>
@@ -3718,7 +3673,7 @@
     <p:bg>
       <p:bgPr>
         <a:solidFill>
-          <a:srgbClr val="0F172A"/>
+          <a:srgbClr val="F1F5F9"/>
         </a:solidFill>
         <a:effectLst/>
       </p:bgPr>
@@ -3755,7 +3710,7 @@
             <a:pPr>
               <a:defRPr sz="3200" b="1">
                 <a:solidFill>
-                  <a:srgbClr val="38BDF8"/>
+                  <a:srgbClr val="4F46E5"/>
                 </a:solidFill>
                 <a:latin typeface="Segoe UI"/>
               </a:defRPr>
@@ -3794,7 +3749,7 @@
               </a:spcAft>
               <a:defRPr sz="1600">
                 <a:solidFill>
-                  <a:srgbClr val="94A3B8"/>
+                  <a:srgbClr val="475569"/>
                 </a:solidFill>
                 <a:latin typeface="Segoe UI"/>
               </a:defRPr>
@@ -3810,7 +3765,7 @@
               </a:spcAft>
               <a:defRPr sz="1600">
                 <a:solidFill>
-                  <a:srgbClr val="94A3B8"/>
+                  <a:srgbClr val="475569"/>
                 </a:solidFill>
                 <a:latin typeface="Segoe UI"/>
               </a:defRPr>
@@ -3826,7 +3781,7 @@
               </a:spcAft>
               <a:defRPr sz="1600">
                 <a:solidFill>
-                  <a:srgbClr val="94A3B8"/>
+                  <a:srgbClr val="475569"/>
                 </a:solidFill>
                 <a:latin typeface="Segoe UI"/>
               </a:defRPr>
@@ -3842,7 +3797,7 @@
               </a:spcAft>
               <a:defRPr sz="1600">
                 <a:solidFill>
-                  <a:srgbClr val="94A3B8"/>
+                  <a:srgbClr val="475569"/>
                 </a:solidFill>
                 <a:latin typeface="Segoe UI"/>
               </a:defRPr>
@@ -3867,7 +3822,7 @@
     <p:bg>
       <p:bgPr>
         <a:solidFill>
-          <a:srgbClr val="0F172A"/>
+          <a:srgbClr val="F1F5F9"/>
         </a:solidFill>
         <a:effectLst/>
       </p:bgPr>
@@ -3904,7 +3859,7 @@
             <a:pPr>
               <a:defRPr sz="3200" b="1">
                 <a:solidFill>
-                  <a:srgbClr val="38BDF8"/>
+                  <a:srgbClr val="4F46E5"/>
                 </a:solidFill>
                 <a:latin typeface="Segoe UI"/>
               </a:defRPr>
@@ -3943,7 +3898,7 @@
               </a:spcAft>
               <a:defRPr sz="1600">
                 <a:solidFill>
-                  <a:srgbClr val="94A3B8"/>
+                  <a:srgbClr val="475569"/>
                 </a:solidFill>
                 <a:latin typeface="Segoe UI"/>
               </a:defRPr>
@@ -3959,7 +3914,7 @@
               </a:spcAft>
               <a:defRPr sz="1600">
                 <a:solidFill>
-                  <a:srgbClr val="94A3B8"/>
+                  <a:srgbClr val="475569"/>
                 </a:solidFill>
                 <a:latin typeface="Segoe UI"/>
               </a:defRPr>
@@ -3975,7 +3930,7 @@
               </a:spcAft>
               <a:defRPr sz="1600">
                 <a:solidFill>
-                  <a:srgbClr val="94A3B8"/>
+                  <a:srgbClr val="475569"/>
                 </a:solidFill>
                 <a:latin typeface="Segoe UI"/>
               </a:defRPr>
@@ -3991,7 +3946,7 @@
               </a:spcAft>
               <a:defRPr sz="1600">
                 <a:solidFill>
-                  <a:srgbClr val="94A3B8"/>
+                  <a:srgbClr val="475569"/>
                 </a:solidFill>
                 <a:latin typeface="Segoe UI"/>
               </a:defRPr>
@@ -4007,7 +3962,7 @@
               </a:spcAft>
               <a:defRPr sz="1600">
                 <a:solidFill>
-                  <a:srgbClr val="94A3B8"/>
+                  <a:srgbClr val="475569"/>
                 </a:solidFill>
                 <a:latin typeface="Segoe UI"/>
               </a:defRPr>
@@ -4032,7 +3987,7 @@
     <p:bg>
       <p:bgPr>
         <a:solidFill>
-          <a:srgbClr val="0F172A"/>
+          <a:srgbClr val="F1F5F9"/>
         </a:solidFill>
         <a:effectLst/>
       </p:bgPr>
@@ -4069,7 +4024,7 @@
             <a:pPr>
               <a:defRPr sz="3200" b="1">
                 <a:solidFill>
-                  <a:srgbClr val="38BDF8"/>
+                  <a:srgbClr val="4F46E5"/>
                 </a:solidFill>
                 <a:latin typeface="Segoe UI"/>
               </a:defRPr>
@@ -4108,7 +4063,7 @@
               </a:spcAft>
               <a:defRPr sz="1600">
                 <a:solidFill>
-                  <a:srgbClr val="94A3B8"/>
+                  <a:srgbClr val="475569"/>
                 </a:solidFill>
                 <a:latin typeface="Segoe UI"/>
               </a:defRPr>
@@ -4124,7 +4079,7 @@
               </a:spcAft>
               <a:defRPr sz="1600">
                 <a:solidFill>
-                  <a:srgbClr val="94A3B8"/>
+                  <a:srgbClr val="475569"/>
                 </a:solidFill>
                 <a:latin typeface="Segoe UI"/>
               </a:defRPr>
@@ -4140,7 +4095,7 @@
               </a:spcAft>
               <a:defRPr sz="1600">
                 <a:solidFill>
-                  <a:srgbClr val="94A3B8"/>
+                  <a:srgbClr val="475569"/>
                 </a:solidFill>
                 <a:latin typeface="Segoe UI"/>
               </a:defRPr>
@@ -4156,7 +4111,7 @@
               </a:spcAft>
               <a:defRPr sz="1600">
                 <a:solidFill>
-                  <a:srgbClr val="94A3B8"/>
+                  <a:srgbClr val="475569"/>
                 </a:solidFill>
                 <a:latin typeface="Segoe UI"/>
               </a:defRPr>
@@ -4172,7 +4127,7 @@
               </a:spcAft>
               <a:defRPr sz="1600">
                 <a:solidFill>
-                  <a:srgbClr val="94A3B8"/>
+                  <a:srgbClr val="475569"/>
                 </a:solidFill>
                 <a:latin typeface="Segoe UI"/>
               </a:defRPr>
@@ -4197,7 +4152,7 @@
     <p:bg>
       <p:bgPr>
         <a:solidFill>
-          <a:srgbClr val="0F172A"/>
+          <a:srgbClr val="F1F5F9"/>
         </a:solidFill>
         <a:effectLst/>
       </p:bgPr>
@@ -4234,7 +4189,7 @@
             <a:pPr>
               <a:defRPr sz="3200" b="1">
                 <a:solidFill>
-                  <a:srgbClr val="38BDF8"/>
+                  <a:srgbClr val="4F46E5"/>
                 </a:solidFill>
                 <a:latin typeface="Segoe UI"/>
               </a:defRPr>
@@ -4273,7 +4228,7 @@
               </a:spcAft>
               <a:defRPr sz="1600">
                 <a:solidFill>
-                  <a:srgbClr val="94A3B8"/>
+                  <a:srgbClr val="475569"/>
                 </a:solidFill>
                 <a:latin typeface="Segoe UI"/>
               </a:defRPr>
@@ -4289,7 +4244,7 @@
               </a:spcAft>
               <a:defRPr sz="1600">
                 <a:solidFill>
-                  <a:srgbClr val="94A3B8"/>
+                  <a:srgbClr val="475569"/>
                 </a:solidFill>
                 <a:latin typeface="Segoe UI"/>
               </a:defRPr>
@@ -4305,7 +4260,7 @@
               </a:spcAft>
               <a:defRPr sz="1600">
                 <a:solidFill>
-                  <a:srgbClr val="94A3B8"/>
+                  <a:srgbClr val="475569"/>
                 </a:solidFill>
                 <a:latin typeface="Segoe UI"/>
               </a:defRPr>
@@ -4321,7 +4276,7 @@
               </a:spcAft>
               <a:defRPr sz="1600">
                 <a:solidFill>
-                  <a:srgbClr val="94A3B8"/>
+                  <a:srgbClr val="475569"/>
                 </a:solidFill>
                 <a:latin typeface="Segoe UI"/>
               </a:defRPr>
@@ -4337,7 +4292,7 @@
               </a:spcAft>
               <a:defRPr sz="1600">
                 <a:solidFill>
-                  <a:srgbClr val="94A3B8"/>
+                  <a:srgbClr val="475569"/>
                 </a:solidFill>
                 <a:latin typeface="Segoe UI"/>
               </a:defRPr>
@@ -4386,7 +4341,7 @@
     <p:bg>
       <p:bgPr>
         <a:solidFill>
-          <a:srgbClr val="0F172A"/>
+          <a:srgbClr val="F1F5F9"/>
         </a:solidFill>
         <a:effectLst/>
       </p:bgPr>
@@ -4423,7 +4378,7 @@
             <a:pPr>
               <a:defRPr sz="3200" b="1">
                 <a:solidFill>
-                  <a:srgbClr val="38BDF8"/>
+                  <a:srgbClr val="4F46E5"/>
                 </a:solidFill>
                 <a:latin typeface="Segoe UI"/>
               </a:defRPr>
@@ -4462,7 +4417,7 @@
               </a:spcAft>
               <a:defRPr sz="1600">
                 <a:solidFill>
-                  <a:srgbClr val="94A3B8"/>
+                  <a:srgbClr val="475569"/>
                 </a:solidFill>
                 <a:latin typeface="Segoe UI"/>
               </a:defRPr>
@@ -4478,7 +4433,7 @@
               </a:spcAft>
               <a:defRPr sz="1600">
                 <a:solidFill>
-                  <a:srgbClr val="94A3B8"/>
+                  <a:srgbClr val="475569"/>
                 </a:solidFill>
                 <a:latin typeface="Segoe UI"/>
               </a:defRPr>
@@ -4494,7 +4449,7 @@
               </a:spcAft>
               <a:defRPr sz="1600">
                 <a:solidFill>
-                  <a:srgbClr val="94A3B8"/>
+                  <a:srgbClr val="475569"/>
                 </a:solidFill>
                 <a:latin typeface="Segoe UI"/>
               </a:defRPr>
@@ -4510,7 +4465,7 @@
               </a:spcAft>
               <a:defRPr sz="1600">
                 <a:solidFill>
-                  <a:srgbClr val="94A3B8"/>
+                  <a:srgbClr val="475569"/>
                 </a:solidFill>
                 <a:latin typeface="Segoe UI"/>
               </a:defRPr>
@@ -4535,7 +4490,7 @@
     <p:bg>
       <p:bgPr>
         <a:solidFill>
-          <a:srgbClr val="0F172A"/>
+          <a:srgbClr val="F1F5F9"/>
         </a:solidFill>
         <a:effectLst/>
       </p:bgPr>
@@ -4572,7 +4527,7 @@
             <a:pPr>
               <a:defRPr sz="3200" b="1">
                 <a:solidFill>
-                  <a:srgbClr val="38BDF8"/>
+                  <a:srgbClr val="4F46E5"/>
                 </a:solidFill>
                 <a:latin typeface="Segoe UI"/>
               </a:defRPr>
@@ -4611,7 +4566,7 @@
               </a:spcAft>
               <a:defRPr sz="1600">
                 <a:solidFill>
-                  <a:srgbClr val="94A3B8"/>
+                  <a:srgbClr val="475569"/>
                 </a:solidFill>
                 <a:latin typeface="Segoe UI"/>
               </a:defRPr>
@@ -4627,7 +4582,7 @@
               </a:spcAft>
               <a:defRPr sz="1600">
                 <a:solidFill>
-                  <a:srgbClr val="94A3B8"/>
+                  <a:srgbClr val="475569"/>
                 </a:solidFill>
                 <a:latin typeface="Segoe UI"/>
               </a:defRPr>
@@ -4643,7 +4598,7 @@
               </a:spcAft>
               <a:defRPr sz="1600">
                 <a:solidFill>
-                  <a:srgbClr val="94A3B8"/>
+                  <a:srgbClr val="475569"/>
                 </a:solidFill>
                 <a:latin typeface="Segoe UI"/>
               </a:defRPr>
@@ -4659,7 +4614,7 @@
               </a:spcAft>
               <a:defRPr sz="1600">
                 <a:solidFill>
-                  <a:srgbClr val="94A3B8"/>
+                  <a:srgbClr val="475569"/>
                 </a:solidFill>
                 <a:latin typeface="Segoe UI"/>
               </a:defRPr>
@@ -4684,7 +4639,7 @@
     <p:bg>
       <p:bgPr>
         <a:solidFill>
-          <a:srgbClr val="0F172A"/>
+          <a:srgbClr val="F1F5F9"/>
         </a:solidFill>
         <a:effectLst/>
       </p:bgPr>
@@ -4721,7 +4676,7 @@
             <a:pPr>
               <a:defRPr sz="3200" b="1">
                 <a:solidFill>
-                  <a:srgbClr val="38BDF8"/>
+                  <a:srgbClr val="4F46E5"/>
                 </a:solidFill>
                 <a:latin typeface="Segoe UI"/>
               </a:defRPr>
@@ -4760,7 +4715,7 @@
               </a:spcAft>
               <a:defRPr sz="1600">
                 <a:solidFill>
-                  <a:srgbClr val="94A3B8"/>
+                  <a:srgbClr val="475569"/>
                 </a:solidFill>
                 <a:latin typeface="Segoe UI"/>
               </a:defRPr>
@@ -4776,7 +4731,7 @@
               </a:spcAft>
               <a:defRPr sz="1600">
                 <a:solidFill>
-                  <a:srgbClr val="94A3B8"/>
+                  <a:srgbClr val="475569"/>
                 </a:solidFill>
                 <a:latin typeface="Segoe UI"/>
               </a:defRPr>
@@ -4792,7 +4747,7 @@
               </a:spcAft>
               <a:defRPr sz="1600">
                 <a:solidFill>
-                  <a:srgbClr val="94A3B8"/>
+                  <a:srgbClr val="475569"/>
                 </a:solidFill>
                 <a:latin typeface="Segoe UI"/>
               </a:defRPr>
@@ -4808,7 +4763,7 @@
               </a:spcAft>
               <a:defRPr sz="1600">
                 <a:solidFill>
-                  <a:srgbClr val="94A3B8"/>
+                  <a:srgbClr val="475569"/>
                 </a:solidFill>
                 <a:latin typeface="Segoe UI"/>
               </a:defRPr>
@@ -4833,7 +4788,7 @@
     <p:bg>
       <p:bgPr>
         <a:solidFill>
-          <a:srgbClr val="0F172A"/>
+          <a:srgbClr val="F1F5F9"/>
         </a:solidFill>
         <a:effectLst/>
       </p:bgPr>
@@ -4870,7 +4825,7 @@
             <a:pPr>
               <a:defRPr sz="3200" b="1">
                 <a:solidFill>
-                  <a:srgbClr val="38BDF8"/>
+                  <a:srgbClr val="4F46E5"/>
                 </a:solidFill>
                 <a:latin typeface="Segoe UI"/>
               </a:defRPr>
@@ -4909,7 +4864,7 @@
               </a:spcAft>
               <a:defRPr sz="1600">
                 <a:solidFill>
-                  <a:srgbClr val="94A3B8"/>
+                  <a:srgbClr val="475569"/>
                 </a:solidFill>
                 <a:latin typeface="Segoe UI"/>
               </a:defRPr>
@@ -4925,7 +4880,7 @@
               </a:spcAft>
               <a:defRPr sz="1600">
                 <a:solidFill>
-                  <a:srgbClr val="94A3B8"/>
+                  <a:srgbClr val="475569"/>
                 </a:solidFill>
                 <a:latin typeface="Segoe UI"/>
               </a:defRPr>
@@ -4941,7 +4896,7 @@
               </a:spcAft>
               <a:defRPr sz="1600">
                 <a:solidFill>
-                  <a:srgbClr val="94A3B8"/>
+                  <a:srgbClr val="475569"/>
                 </a:solidFill>
                 <a:latin typeface="Segoe UI"/>
               </a:defRPr>
@@ -4957,7 +4912,7 @@
               </a:spcAft>
               <a:defRPr sz="1600">
                 <a:solidFill>
-                  <a:srgbClr val="94A3B8"/>
+                  <a:srgbClr val="475569"/>
                 </a:solidFill>
                 <a:latin typeface="Segoe UI"/>
               </a:defRPr>
@@ -4982,7 +4937,7 @@
     <p:bg>
       <p:bgPr>
         <a:solidFill>
-          <a:srgbClr val="0F172A"/>
+          <a:srgbClr val="F1F5F9"/>
         </a:solidFill>
         <a:effectLst/>
       </p:bgPr>
@@ -5019,7 +4974,7 @@
             <a:pPr>
               <a:defRPr sz="3200" b="1">
                 <a:solidFill>
-                  <a:srgbClr val="38BDF8"/>
+                  <a:srgbClr val="4F46E5"/>
                 </a:solidFill>
                 <a:latin typeface="Segoe UI"/>
               </a:defRPr>
@@ -5058,7 +5013,7 @@
               </a:spcAft>
               <a:defRPr sz="1600">
                 <a:solidFill>
-                  <a:srgbClr val="94A3B8"/>
+                  <a:srgbClr val="475569"/>
                 </a:solidFill>
                 <a:latin typeface="Segoe UI"/>
               </a:defRPr>
@@ -5074,7 +5029,7 @@
               </a:spcAft>
               <a:defRPr sz="1600">
                 <a:solidFill>
-                  <a:srgbClr val="94A3B8"/>
+                  <a:srgbClr val="475569"/>
                 </a:solidFill>
                 <a:latin typeface="Segoe UI"/>
               </a:defRPr>
@@ -5090,7 +5045,7 @@
               </a:spcAft>
               <a:defRPr sz="1600">
                 <a:solidFill>
-                  <a:srgbClr val="94A3B8"/>
+                  <a:srgbClr val="475569"/>
                 </a:solidFill>
                 <a:latin typeface="Segoe UI"/>
               </a:defRPr>
@@ -5115,7 +5070,7 @@
     <p:bg>
       <p:bgPr>
         <a:solidFill>
-          <a:srgbClr val="0F172A"/>
+          <a:srgbClr val="F1F5F9"/>
         </a:solidFill>
         <a:effectLst/>
       </p:bgPr>
@@ -5152,7 +5107,7 @@
             <a:pPr>
               <a:defRPr sz="3200" b="1">
                 <a:solidFill>
-                  <a:srgbClr val="38BDF8"/>
+                  <a:srgbClr val="4F46E5"/>
                 </a:solidFill>
                 <a:latin typeface="Segoe UI"/>
               </a:defRPr>
@@ -5191,7 +5146,7 @@
               </a:spcAft>
               <a:defRPr sz="1600">
                 <a:solidFill>
-                  <a:srgbClr val="94A3B8"/>
+                  <a:srgbClr val="475569"/>
                 </a:solidFill>
                 <a:latin typeface="Segoe UI"/>
               </a:defRPr>
@@ -5207,7 +5162,7 @@
               </a:spcAft>
               <a:defRPr sz="1600">
                 <a:solidFill>
-                  <a:srgbClr val="94A3B8"/>
+                  <a:srgbClr val="475569"/>
                 </a:solidFill>
                 <a:latin typeface="Segoe UI"/>
               </a:defRPr>
@@ -5223,7 +5178,7 @@
               </a:spcAft>
               <a:defRPr sz="1600">
                 <a:solidFill>
-                  <a:srgbClr val="94A3B8"/>
+                  <a:srgbClr val="475569"/>
                 </a:solidFill>
                 <a:latin typeface="Segoe UI"/>
               </a:defRPr>
@@ -5239,7 +5194,7 @@
               </a:spcAft>
               <a:defRPr sz="1600">
                 <a:solidFill>
-                  <a:srgbClr val="94A3B8"/>
+                  <a:srgbClr val="475569"/>
                 </a:solidFill>
                 <a:latin typeface="Segoe UI"/>
               </a:defRPr>
@@ -5255,7 +5210,7 @@
               </a:spcAft>
               <a:defRPr sz="1600">
                 <a:solidFill>
-                  <a:srgbClr val="94A3B8"/>
+                  <a:srgbClr val="475569"/>
                 </a:solidFill>
                 <a:latin typeface="Segoe UI"/>
               </a:defRPr>
@@ -5280,7 +5235,7 @@
     <p:bg>
       <p:bgPr>
         <a:solidFill>
-          <a:srgbClr val="0F172A"/>
+          <a:srgbClr val="F1F5F9"/>
         </a:solidFill>
         <a:effectLst/>
       </p:bgPr>
@@ -5317,7 +5272,7 @@
             <a:pPr>
               <a:defRPr sz="3200" b="1">
                 <a:solidFill>
-                  <a:srgbClr val="38BDF8"/>
+                  <a:srgbClr val="4F46E5"/>
                 </a:solidFill>
                 <a:latin typeface="Segoe UI"/>
               </a:defRPr>
@@ -5356,7 +5311,7 @@
               </a:spcAft>
               <a:defRPr sz="1600">
                 <a:solidFill>
-                  <a:srgbClr val="94A3B8"/>
+                  <a:srgbClr val="475569"/>
                 </a:solidFill>
                 <a:latin typeface="Segoe UI"/>
               </a:defRPr>
@@ -5372,7 +5327,7 @@
               </a:spcAft>
               <a:defRPr sz="1600">
                 <a:solidFill>
-                  <a:srgbClr val="94A3B8"/>
+                  <a:srgbClr val="475569"/>
                 </a:solidFill>
                 <a:latin typeface="Segoe UI"/>
               </a:defRPr>
@@ -5388,7 +5343,7 @@
               </a:spcAft>
               <a:defRPr sz="1600">
                 <a:solidFill>
-                  <a:srgbClr val="94A3B8"/>
+                  <a:srgbClr val="475569"/>
                 </a:solidFill>
                 <a:latin typeface="Segoe UI"/>
               </a:defRPr>
@@ -5404,7 +5359,7 @@
               </a:spcAft>
               <a:defRPr sz="1600">
                 <a:solidFill>
-                  <a:srgbClr val="94A3B8"/>
+                  <a:srgbClr val="475569"/>
                 </a:solidFill>
                 <a:latin typeface="Segoe UI"/>
               </a:defRPr>
@@ -5429,7 +5384,7 @@
     <p:bg>
       <p:bgPr>
         <a:solidFill>
-          <a:srgbClr val="0F172A"/>
+          <a:srgbClr val="F1F5F9"/>
         </a:solidFill>
         <a:effectLst/>
       </p:bgPr>
@@ -5466,7 +5421,7 @@
             <a:pPr>
               <a:defRPr sz="3200" b="1">
                 <a:solidFill>
-                  <a:srgbClr val="38BDF8"/>
+                  <a:srgbClr val="4F46E5"/>
                 </a:solidFill>
                 <a:latin typeface="Segoe UI"/>
               </a:defRPr>
@@ -5505,7 +5460,7 @@
               </a:spcAft>
               <a:defRPr sz="1600">
                 <a:solidFill>
-                  <a:srgbClr val="94A3B8"/>
+                  <a:srgbClr val="475569"/>
                 </a:solidFill>
                 <a:latin typeface="Segoe UI"/>
               </a:defRPr>
@@ -5521,7 +5476,7 @@
               </a:spcAft>
               <a:defRPr sz="1800">
                 <a:solidFill>
-                  <a:srgbClr val="94A3B8"/>
+                  <a:srgbClr val="475569"/>
                 </a:solidFill>
                 <a:latin typeface="Segoe UI"/>
               </a:defRPr>
@@ -5537,7 +5492,7 @@
               </a:spcAft>
               <a:defRPr sz="1600">
                 <a:solidFill>
-                  <a:srgbClr val="94A3B8"/>
+                  <a:srgbClr val="475569"/>
                 </a:solidFill>
                 <a:latin typeface="Segoe UI"/>
               </a:defRPr>
@@ -5553,7 +5508,7 @@
               </a:spcAft>
               <a:defRPr sz="1600">
                 <a:solidFill>
-                  <a:srgbClr val="94A3B8"/>
+                  <a:srgbClr val="475569"/>
                 </a:solidFill>
                 <a:latin typeface="Segoe UI"/>
               </a:defRPr>
@@ -5569,7 +5524,7 @@
               </a:spcAft>
               <a:defRPr sz="1600">
                 <a:solidFill>
-                  <a:srgbClr val="94A3B8"/>
+                  <a:srgbClr val="475569"/>
                 </a:solidFill>
                 <a:latin typeface="Segoe UI"/>
               </a:defRPr>
@@ -6910,7 +6865,7 @@
     <p:bg>
       <p:bgPr>
         <a:solidFill>
-          <a:srgbClr val="0F172A"/>
+          <a:srgbClr val="F1F5F9"/>
         </a:solidFill>
         <a:effectLst/>
       </p:bgPr>
@@ -6947,7 +6902,7 @@
             <a:pPr>
               <a:defRPr sz="3200" b="1">
                 <a:solidFill>
-                  <a:srgbClr val="38BDF8"/>
+                  <a:srgbClr val="4F46E5"/>
                 </a:solidFill>
                 <a:latin typeface="Segoe UI"/>
               </a:defRPr>
@@ -6986,7 +6941,7 @@
               </a:spcAft>
               <a:defRPr sz="1600">
                 <a:solidFill>
-                  <a:srgbClr val="94A3B8"/>
+                  <a:srgbClr val="475569"/>
                 </a:solidFill>
                 <a:latin typeface="Segoe UI"/>
               </a:defRPr>
@@ -7002,7 +6957,7 @@
               </a:spcAft>
               <a:defRPr sz="1800">
                 <a:solidFill>
-                  <a:srgbClr val="94A3B8"/>
+                  <a:srgbClr val="475569"/>
                 </a:solidFill>
                 <a:latin typeface="Segoe UI"/>
               </a:defRPr>
@@ -7018,7 +6973,7 @@
               </a:spcAft>
               <a:defRPr sz="1600">
                 <a:solidFill>
-                  <a:srgbClr val="94A3B8"/>
+                  <a:srgbClr val="475569"/>
                 </a:solidFill>
                 <a:latin typeface="Segoe UI"/>
               </a:defRPr>
@@ -7034,7 +6989,7 @@
               </a:spcAft>
               <a:defRPr sz="1600">
                 <a:solidFill>
-                  <a:srgbClr val="94A3B8"/>
+                  <a:srgbClr val="475569"/>
                 </a:solidFill>
                 <a:latin typeface="Segoe UI"/>
               </a:defRPr>
@@ -7050,7 +7005,7 @@
               </a:spcAft>
               <a:defRPr sz="1600">
                 <a:solidFill>
-                  <a:srgbClr val="94A3B8"/>
+                  <a:srgbClr val="475569"/>
                 </a:solidFill>
                 <a:latin typeface="Segoe UI"/>
               </a:defRPr>
@@ -7066,7 +7021,7 @@
               </a:spcAft>
               <a:defRPr sz="1600">
                 <a:solidFill>
-                  <a:srgbClr val="94A3B8"/>
+                  <a:srgbClr val="475569"/>
                 </a:solidFill>
                 <a:latin typeface="Segoe UI"/>
               </a:defRPr>
@@ -8718,7 +8673,7 @@
     <p:bg>
       <p:bgPr>
         <a:solidFill>
-          <a:srgbClr val="0F172A"/>
+          <a:srgbClr val="F1F5F9"/>
         </a:solidFill>
         <a:effectLst/>
       </p:bgPr>
@@ -8755,7 +8710,7 @@
             <a:pPr>
               <a:defRPr sz="3200" b="1">
                 <a:solidFill>
-                  <a:srgbClr val="38BDF8"/>
+                  <a:srgbClr val="4F46E5"/>
                 </a:solidFill>
                 <a:latin typeface="Segoe UI"/>
               </a:defRPr>
@@ -8794,7 +8749,7 @@
               </a:spcAft>
               <a:defRPr sz="1600">
                 <a:solidFill>
-                  <a:srgbClr val="94A3B8"/>
+                  <a:srgbClr val="475569"/>
                 </a:solidFill>
                 <a:latin typeface="Segoe UI"/>
               </a:defRPr>
@@ -8810,7 +8765,7 @@
               </a:spcAft>
               <a:defRPr sz="1600">
                 <a:solidFill>
-                  <a:srgbClr val="94A3B8"/>
+                  <a:srgbClr val="475569"/>
                 </a:solidFill>
                 <a:latin typeface="Segoe UI"/>
               </a:defRPr>
@@ -8826,7 +8781,7 @@
               </a:spcAft>
               <a:defRPr sz="1600">
                 <a:solidFill>
-                  <a:srgbClr val="94A3B8"/>
+                  <a:srgbClr val="475569"/>
                 </a:solidFill>
                 <a:latin typeface="Segoe UI"/>
               </a:defRPr>
@@ -8842,7 +8797,7 @@
               </a:spcAft>
               <a:defRPr sz="1600">
                 <a:solidFill>
-                  <a:srgbClr val="94A3B8"/>
+                  <a:srgbClr val="475569"/>
                 </a:solidFill>
                 <a:latin typeface="Segoe UI"/>
               </a:defRPr>
@@ -8858,7 +8813,7 @@
               </a:spcAft>
               <a:defRPr sz="1600">
                 <a:solidFill>
-                  <a:srgbClr val="94A3B8"/>
+                  <a:srgbClr val="475569"/>
                 </a:solidFill>
                 <a:latin typeface="Segoe UI"/>
               </a:defRPr>
@@ -8874,7 +8829,7 @@
               </a:spcAft>
               <a:defRPr sz="1600">
                 <a:solidFill>
-                  <a:srgbClr val="94A3B8"/>
+                  <a:srgbClr val="475569"/>
                 </a:solidFill>
                 <a:latin typeface="Segoe UI"/>
               </a:defRPr>
@@ -8890,7 +8845,7 @@
               </a:spcAft>
               <a:defRPr sz="1600">
                 <a:solidFill>
-                  <a:srgbClr val="94A3B8"/>
+                  <a:srgbClr val="475569"/>
                 </a:solidFill>
                 <a:latin typeface="Segoe UI"/>
               </a:defRPr>
@@ -8915,7 +8870,7 @@
     <p:bg>
       <p:bgPr>
         <a:solidFill>
-          <a:srgbClr val="0F172A"/>
+          <a:srgbClr val="F1F5F9"/>
         </a:solidFill>
         <a:effectLst/>
       </p:bgPr>
@@ -8952,7 +8907,7 @@
             <a:pPr>
               <a:defRPr sz="3200" b="1">
                 <a:solidFill>
-                  <a:srgbClr val="38BDF8"/>
+                  <a:srgbClr val="4F46E5"/>
                 </a:solidFill>
                 <a:latin typeface="Segoe UI"/>
               </a:defRPr>
@@ -8991,7 +8946,7 @@
               </a:spcAft>
               <a:defRPr sz="1600">
                 <a:solidFill>
-                  <a:srgbClr val="94A3B8"/>
+                  <a:srgbClr val="475569"/>
                 </a:solidFill>
                 <a:latin typeface="Segoe UI"/>
               </a:defRPr>
@@ -9007,7 +8962,7 @@
               </a:spcAft>
               <a:defRPr sz="1600">
                 <a:solidFill>
-                  <a:srgbClr val="94A3B8"/>
+                  <a:srgbClr val="475569"/>
                 </a:solidFill>
                 <a:latin typeface="Segoe UI"/>
               </a:defRPr>
@@ -9023,7 +8978,7 @@
               </a:spcAft>
               <a:defRPr sz="1600">
                 <a:solidFill>
-                  <a:srgbClr val="94A3B8"/>
+                  <a:srgbClr val="475569"/>
                 </a:solidFill>
                 <a:latin typeface="Segoe UI"/>
               </a:defRPr>
@@ -9039,7 +8994,7 @@
               </a:spcAft>
               <a:defRPr sz="1600">
                 <a:solidFill>
-                  <a:srgbClr val="94A3B8"/>
+                  <a:srgbClr val="475569"/>
                 </a:solidFill>
                 <a:latin typeface="Segoe UI"/>
               </a:defRPr>
@@ -9088,7 +9043,7 @@
     <p:bg>
       <p:bgPr>
         <a:solidFill>
-          <a:srgbClr val="0F172A"/>
+          <a:srgbClr val="F1F5F9"/>
         </a:solidFill>
         <a:effectLst/>
       </p:bgPr>
@@ -9125,7 +9080,7 @@
             <a:pPr>
               <a:defRPr sz="3200" b="1">
                 <a:solidFill>
-                  <a:srgbClr val="38BDF8"/>
+                  <a:srgbClr val="4F46E5"/>
                 </a:solidFill>
                 <a:latin typeface="Segoe UI"/>
               </a:defRPr>
@@ -9164,7 +9119,7 @@
               </a:spcAft>
               <a:defRPr sz="1600">
                 <a:solidFill>
-                  <a:srgbClr val="94A3B8"/>
+                  <a:srgbClr val="475569"/>
                 </a:solidFill>
                 <a:latin typeface="Segoe UI"/>
               </a:defRPr>
@@ -9180,7 +9135,7 @@
               </a:spcAft>
               <a:defRPr sz="1600">
                 <a:solidFill>
-                  <a:srgbClr val="94A3B8"/>
+                  <a:srgbClr val="475569"/>
                 </a:solidFill>
                 <a:latin typeface="Segoe UI"/>
               </a:defRPr>
@@ -9196,7 +9151,7 @@
               </a:spcAft>
               <a:defRPr sz="1600">
                 <a:solidFill>
-                  <a:srgbClr val="94A3B8"/>
+                  <a:srgbClr val="475569"/>
                 </a:solidFill>
                 <a:latin typeface="Segoe UI"/>
               </a:defRPr>
@@ -9212,7 +9167,7 @@
               </a:spcAft>
               <a:defRPr sz="1600">
                 <a:solidFill>
-                  <a:srgbClr val="94A3B8"/>
+                  <a:srgbClr val="475569"/>
                 </a:solidFill>
                 <a:latin typeface="Segoe UI"/>
               </a:defRPr>
@@ -9261,7 +9216,7 @@
     <p:bg>
       <p:bgPr>
         <a:solidFill>
-          <a:srgbClr val="0F172A"/>
+          <a:srgbClr val="F1F5F9"/>
         </a:solidFill>
         <a:effectLst/>
       </p:bgPr>
@@ -9298,7 +9253,7 @@
             <a:pPr>
               <a:defRPr sz="3200" b="1">
                 <a:solidFill>
-                  <a:srgbClr val="38BDF8"/>
+                  <a:srgbClr val="4F46E5"/>
                 </a:solidFill>
                 <a:latin typeface="Segoe UI"/>
               </a:defRPr>
@@ -9337,7 +9292,7 @@
               </a:spcAft>
               <a:defRPr sz="1600">
                 <a:solidFill>
-                  <a:srgbClr val="94A3B8"/>
+                  <a:srgbClr val="475569"/>
                 </a:solidFill>
                 <a:latin typeface="Segoe UI"/>
               </a:defRPr>
@@ -9353,7 +9308,7 @@
               </a:spcAft>
               <a:defRPr sz="1600">
                 <a:solidFill>
-                  <a:srgbClr val="94A3B8"/>
+                  <a:srgbClr val="475569"/>
                 </a:solidFill>
                 <a:latin typeface="Segoe UI"/>
               </a:defRPr>
@@ -9369,7 +9324,7 @@
               </a:spcAft>
               <a:defRPr sz="1600">
                 <a:solidFill>
-                  <a:srgbClr val="94A3B8"/>
+                  <a:srgbClr val="475569"/>
                 </a:solidFill>
                 <a:latin typeface="Segoe UI"/>
               </a:defRPr>
@@ -9385,7 +9340,7 @@
               </a:spcAft>
               <a:defRPr sz="1600">
                 <a:solidFill>
-                  <a:srgbClr val="94A3B8"/>
+                  <a:srgbClr val="475569"/>
                 </a:solidFill>
                 <a:latin typeface="Segoe UI"/>
               </a:defRPr>
@@ -9401,7 +9356,7 @@
               </a:spcAft>
               <a:defRPr sz="1600">
                 <a:solidFill>
-                  <a:srgbClr val="94A3B8"/>
+                  <a:srgbClr val="475569"/>
                 </a:solidFill>
                 <a:latin typeface="Segoe UI"/>
               </a:defRPr>
@@ -10327,7 +10282,7 @@
     <p:bg>
       <p:bgPr>
         <a:solidFill>
-          <a:srgbClr val="0F172A"/>
+          <a:srgbClr val="F1F5F9"/>
         </a:solidFill>
         <a:effectLst/>
       </p:bgPr>
@@ -10364,7 +10319,7 @@
             <a:pPr>
               <a:defRPr sz="3200" b="1">
                 <a:solidFill>
-                  <a:srgbClr val="38BDF8"/>
+                  <a:srgbClr val="4F46E5"/>
                 </a:solidFill>
                 <a:latin typeface="Segoe UI"/>
               </a:defRPr>
@@ -10403,7 +10358,7 @@
               </a:spcAft>
               <a:defRPr sz="1600">
                 <a:solidFill>
-                  <a:srgbClr val="94A3B8"/>
+                  <a:srgbClr val="475569"/>
                 </a:solidFill>
                 <a:latin typeface="Segoe UI"/>
               </a:defRPr>
@@ -10419,7 +10374,7 @@
               </a:spcAft>
               <a:defRPr sz="1600">
                 <a:solidFill>
-                  <a:srgbClr val="94A3B8"/>
+                  <a:srgbClr val="475569"/>
                 </a:solidFill>
                 <a:latin typeface="Segoe UI"/>
               </a:defRPr>
@@ -10435,7 +10390,7 @@
               </a:spcAft>
               <a:defRPr sz="1600">
                 <a:solidFill>
-                  <a:srgbClr val="94A3B8"/>
+                  <a:srgbClr val="475569"/>
                 </a:solidFill>
                 <a:latin typeface="Segoe UI"/>
               </a:defRPr>
@@ -10451,7 +10406,7 @@
               </a:spcAft>
               <a:defRPr sz="1600">
                 <a:solidFill>
-                  <a:srgbClr val="94A3B8"/>
+                  <a:srgbClr val="475569"/>
                 </a:solidFill>
                 <a:latin typeface="Segoe UI"/>
               </a:defRPr>
@@ -10467,7 +10422,7 @@
               </a:spcAft>
               <a:defRPr sz="1600">
                 <a:solidFill>
-                  <a:srgbClr val="94A3B8"/>
+                  <a:srgbClr val="475569"/>
                 </a:solidFill>
                 <a:latin typeface="Segoe UI"/>
               </a:defRPr>
@@ -10516,7 +10471,7 @@
     <p:bg>
       <p:bgPr>
         <a:solidFill>
-          <a:srgbClr val="0F172A"/>
+          <a:srgbClr val="F1F5F9"/>
         </a:solidFill>
         <a:effectLst/>
       </p:bgPr>
@@ -10553,7 +10508,7 @@
             <a:pPr>
               <a:defRPr sz="3200" b="1">
                 <a:solidFill>
-                  <a:srgbClr val="38BDF8"/>
+                  <a:srgbClr val="4F46E5"/>
                 </a:solidFill>
                 <a:latin typeface="Segoe UI"/>
               </a:defRPr>
@@ -10592,7 +10547,7 @@
               </a:spcAft>
               <a:defRPr sz="1600">
                 <a:solidFill>
-                  <a:srgbClr val="94A3B8"/>
+                  <a:srgbClr val="475569"/>
                 </a:solidFill>
                 <a:latin typeface="Segoe UI"/>
               </a:defRPr>
@@ -10608,7 +10563,7 @@
               </a:spcAft>
               <a:defRPr sz="1600">
                 <a:solidFill>
-                  <a:srgbClr val="94A3B8"/>
+                  <a:srgbClr val="475569"/>
                 </a:solidFill>
                 <a:latin typeface="Segoe UI"/>
               </a:defRPr>
@@ -10624,7 +10579,7 @@
               </a:spcAft>
               <a:defRPr sz="1600">
                 <a:solidFill>
-                  <a:srgbClr val="94A3B8"/>
+                  <a:srgbClr val="475569"/>
                 </a:solidFill>
                 <a:latin typeface="Segoe UI"/>
               </a:defRPr>
@@ -10640,7 +10595,7 @@
               </a:spcAft>
               <a:defRPr sz="1600">
                 <a:solidFill>
-                  <a:srgbClr val="94A3B8"/>
+                  <a:srgbClr val="475569"/>
                 </a:solidFill>
                 <a:latin typeface="Segoe UI"/>
               </a:defRPr>
@@ -10656,7 +10611,7 @@
               </a:spcAft>
               <a:defRPr sz="1600">
                 <a:solidFill>
-                  <a:srgbClr val="94A3B8"/>
+                  <a:srgbClr val="475569"/>
                 </a:solidFill>
                 <a:latin typeface="Segoe UI"/>
               </a:defRPr>
@@ -12363,7 +12318,7 @@
     <p:bg>
       <p:bgPr>
         <a:solidFill>
-          <a:srgbClr val="0F172A"/>
+          <a:srgbClr val="F1F5F9"/>
         </a:solidFill>
         <a:effectLst/>
       </p:bgPr>
@@ -12400,7 +12355,7 @@
             <a:pPr>
               <a:defRPr sz="3200" b="1">
                 <a:solidFill>
-                  <a:srgbClr val="38BDF8"/>
+                  <a:srgbClr val="4F46E5"/>
                 </a:solidFill>
                 <a:latin typeface="Segoe UI"/>
               </a:defRPr>
@@ -12439,7 +12394,7 @@
               </a:spcAft>
               <a:defRPr sz="1600">
                 <a:solidFill>
-                  <a:srgbClr val="94A3B8"/>
+                  <a:srgbClr val="475569"/>
                 </a:solidFill>
                 <a:latin typeface="Segoe UI"/>
               </a:defRPr>
@@ -12455,7 +12410,7 @@
               </a:spcAft>
               <a:defRPr sz="1600">
                 <a:solidFill>
-                  <a:srgbClr val="94A3B8"/>
+                  <a:srgbClr val="475569"/>
                 </a:solidFill>
                 <a:latin typeface="Segoe UI"/>
               </a:defRPr>
@@ -12471,7 +12426,7 @@
               </a:spcAft>
               <a:defRPr sz="1600">
                 <a:solidFill>
-                  <a:srgbClr val="94A3B8"/>
+                  <a:srgbClr val="475569"/>
                 </a:solidFill>
                 <a:latin typeface="Segoe UI"/>
               </a:defRPr>
@@ -12487,7 +12442,7 @@
               </a:spcAft>
               <a:defRPr sz="1600">
                 <a:solidFill>
-                  <a:srgbClr val="94A3B8"/>
+                  <a:srgbClr val="475569"/>
                 </a:solidFill>
                 <a:latin typeface="Segoe UI"/>
               </a:defRPr>
@@ -12536,7 +12491,7 @@
     <p:bg>
       <p:bgPr>
         <a:solidFill>
-          <a:srgbClr val="0F172A"/>
+          <a:srgbClr val="F1F5F9"/>
         </a:solidFill>
         <a:effectLst/>
       </p:bgPr>
@@ -12573,7 +12528,7 @@
             <a:pPr>
               <a:defRPr sz="3200" b="1">
                 <a:solidFill>
-                  <a:srgbClr val="38BDF8"/>
+                  <a:srgbClr val="4F46E5"/>
                 </a:solidFill>
                 <a:latin typeface="Segoe UI"/>
               </a:defRPr>
@@ -12612,7 +12567,7 @@
               </a:spcAft>
               <a:defRPr sz="1600">
                 <a:solidFill>
-                  <a:srgbClr val="94A3B8"/>
+                  <a:srgbClr val="475569"/>
                 </a:solidFill>
                 <a:latin typeface="Segoe UI"/>
               </a:defRPr>
@@ -12628,7 +12583,7 @@
               </a:spcAft>
               <a:defRPr sz="1600">
                 <a:solidFill>
-                  <a:srgbClr val="94A3B8"/>
+                  <a:srgbClr val="475569"/>
                 </a:solidFill>
                 <a:latin typeface="Segoe UI"/>
               </a:defRPr>
@@ -12644,7 +12599,7 @@
               </a:spcAft>
               <a:defRPr sz="1600">
                 <a:solidFill>
-                  <a:srgbClr val="94A3B8"/>
+                  <a:srgbClr val="475569"/>
                 </a:solidFill>
                 <a:latin typeface="Segoe UI"/>
               </a:defRPr>
@@ -12660,7 +12615,7 @@
               </a:spcAft>
               <a:defRPr sz="1600">
                 <a:solidFill>
-                  <a:srgbClr val="94A3B8"/>
+                  <a:srgbClr val="475569"/>
                 </a:solidFill>
                 <a:latin typeface="Segoe UI"/>
               </a:defRPr>
@@ -12676,7 +12631,7 @@
               </a:spcAft>
               <a:defRPr sz="1600">
                 <a:solidFill>
-                  <a:srgbClr val="94A3B8"/>
+                  <a:srgbClr val="475569"/>
                 </a:solidFill>
                 <a:latin typeface="Segoe UI"/>
               </a:defRPr>
@@ -12725,7 +12680,7 @@
     <p:bg>
       <p:bgPr>
         <a:solidFill>
-          <a:srgbClr val="0F172A"/>
+          <a:srgbClr val="F1F5F9"/>
         </a:solidFill>
         <a:effectLst/>
       </p:bgPr>
@@ -12762,7 +12717,7 @@
             <a:pPr>
               <a:defRPr sz="3200" b="1">
                 <a:solidFill>
-                  <a:srgbClr val="38BDF8"/>
+                  <a:srgbClr val="4F46E5"/>
                 </a:solidFill>
                 <a:latin typeface="Segoe UI"/>
               </a:defRPr>
@@ -12801,7 +12756,7 @@
               </a:spcAft>
               <a:defRPr sz="1600">
                 <a:solidFill>
-                  <a:srgbClr val="94A3B8"/>
+                  <a:srgbClr val="475569"/>
                 </a:solidFill>
                 <a:latin typeface="Segoe UI"/>
               </a:defRPr>
@@ -12817,7 +12772,7 @@
               </a:spcAft>
               <a:defRPr sz="1600">
                 <a:solidFill>
-                  <a:srgbClr val="94A3B8"/>
+                  <a:srgbClr val="475569"/>
                 </a:solidFill>
                 <a:latin typeface="Segoe UI"/>
               </a:defRPr>
@@ -12833,7 +12788,7 @@
               </a:spcAft>
               <a:defRPr sz="1600">
                 <a:solidFill>
-                  <a:srgbClr val="94A3B8"/>
+                  <a:srgbClr val="475569"/>
                 </a:solidFill>
                 <a:latin typeface="Segoe UI"/>
               </a:defRPr>
@@ -12849,7 +12804,7 @@
               </a:spcAft>
               <a:defRPr sz="1600">
                 <a:solidFill>
-                  <a:srgbClr val="94A3B8"/>
+                  <a:srgbClr val="475569"/>
                 </a:solidFill>
                 <a:latin typeface="Segoe UI"/>
               </a:defRPr>
@@ -12865,7 +12820,7 @@
               </a:spcAft>
               <a:defRPr sz="1600">
                 <a:solidFill>
-                  <a:srgbClr val="94A3B8"/>
+                  <a:srgbClr val="475569"/>
                 </a:solidFill>
                 <a:latin typeface="Segoe UI"/>
               </a:defRPr>
@@ -12881,7 +12836,7 @@
               </a:spcAft>
               <a:defRPr sz="1600">
                 <a:solidFill>
-                  <a:srgbClr val="94A3B8"/>
+                  <a:srgbClr val="475569"/>
                 </a:solidFill>
                 <a:latin typeface="Segoe UI"/>
               </a:defRPr>
@@ -12897,7 +12852,7 @@
               </a:spcAft>
               <a:defRPr sz="1600">
                 <a:solidFill>
-                  <a:srgbClr val="94A3B8"/>
+                  <a:srgbClr val="475569"/>
                 </a:solidFill>
                 <a:latin typeface="Segoe UI"/>
               </a:defRPr>
@@ -12922,7 +12877,7 @@
     <p:bg>
       <p:bgPr>
         <a:solidFill>
-          <a:srgbClr val="0F172A"/>
+          <a:srgbClr val="F1F5F9"/>
         </a:solidFill>
         <a:effectLst/>
       </p:bgPr>
@@ -12959,7 +12914,7 @@
             <a:pPr>
               <a:defRPr sz="3200" b="1">
                 <a:solidFill>
-                  <a:srgbClr val="38BDF8"/>
+                  <a:srgbClr val="4F46E5"/>
                 </a:solidFill>
                 <a:latin typeface="Segoe UI"/>
               </a:defRPr>
@@ -12998,7 +12953,7 @@
               </a:spcAft>
               <a:defRPr sz="1600">
                 <a:solidFill>
-                  <a:srgbClr val="94A3B8"/>
+                  <a:srgbClr val="475569"/>
                 </a:solidFill>
                 <a:latin typeface="Segoe UI"/>
               </a:defRPr>
@@ -13014,7 +12969,7 @@
               </a:spcAft>
               <a:defRPr sz="1600">
                 <a:solidFill>
-                  <a:srgbClr val="94A3B8"/>
+                  <a:srgbClr val="475569"/>
                 </a:solidFill>
                 <a:latin typeface="Segoe UI"/>
               </a:defRPr>
@@ -13030,7 +12985,7 @@
               </a:spcAft>
               <a:defRPr sz="1600">
                 <a:solidFill>
-                  <a:srgbClr val="94A3B8"/>
+                  <a:srgbClr val="475569"/>
                 </a:solidFill>
                 <a:latin typeface="Segoe UI"/>
               </a:defRPr>
@@ -13046,7 +13001,7 @@
               </a:spcAft>
               <a:defRPr sz="1600">
                 <a:solidFill>
-                  <a:srgbClr val="94A3B8"/>
+                  <a:srgbClr val="475569"/>
                 </a:solidFill>
                 <a:latin typeface="Segoe UI"/>
               </a:defRPr>
@@ -13071,7 +13026,7 @@
     <p:bg>
       <p:bgPr>
         <a:solidFill>
-          <a:srgbClr val="0F172A"/>
+          <a:srgbClr val="F1F5F9"/>
         </a:solidFill>
         <a:effectLst/>
       </p:bgPr>
@@ -13108,7 +13063,7 @@
             <a:pPr>
               <a:defRPr sz="3200" b="1">
                 <a:solidFill>
-                  <a:srgbClr val="38BDF8"/>
+                  <a:srgbClr val="4F46E5"/>
                 </a:solidFill>
                 <a:latin typeface="Segoe UI"/>
               </a:defRPr>
@@ -13147,7 +13102,7 @@
               </a:spcAft>
               <a:defRPr sz="2000">
                 <a:solidFill>
-                  <a:srgbClr val="94A3B8"/>
+                  <a:srgbClr val="475569"/>
                 </a:solidFill>
                 <a:latin typeface="Segoe UI"/>
               </a:defRPr>
@@ -13188,7 +13143,7 @@
             <a:pPr algn="ctr">
               <a:defRPr sz="3600" b="1">
                 <a:solidFill>
-                  <a:srgbClr val="38BDF8"/>
+                  <a:srgbClr val="4F46E5"/>
                 </a:solidFill>
                 <a:latin typeface="Segoe UI"/>
               </a:defRPr>
@@ -13218,7 +13173,7 @@
     <p:bg>
       <p:bgPr>
         <a:solidFill>
-          <a:srgbClr val="0F172A"/>
+          <a:srgbClr val="F1F5F9"/>
         </a:solidFill>
         <a:effectLst/>
       </p:bgPr>
@@ -13255,7 +13210,7 @@
             <a:pPr>
               <a:defRPr sz="3200" b="1">
                 <a:solidFill>
-                  <a:srgbClr val="38BDF8"/>
+                  <a:srgbClr val="4F46E5"/>
                 </a:solidFill>
                 <a:latin typeface="Segoe UI"/>
               </a:defRPr>
@@ -13294,7 +13249,7 @@
               </a:spcAft>
               <a:defRPr sz="1600">
                 <a:solidFill>
-                  <a:srgbClr val="94A3B8"/>
+                  <a:srgbClr val="475569"/>
                 </a:solidFill>
                 <a:latin typeface="Segoe UI"/>
               </a:defRPr>
@@ -13310,7 +13265,7 @@
               </a:spcAft>
               <a:defRPr sz="1600">
                 <a:solidFill>
-                  <a:srgbClr val="94A3B8"/>
+                  <a:srgbClr val="475569"/>
                 </a:solidFill>
                 <a:latin typeface="Segoe UI"/>
               </a:defRPr>
@@ -13326,7 +13281,7 @@
               </a:spcAft>
               <a:defRPr sz="1600">
                 <a:solidFill>
-                  <a:srgbClr val="94A3B8"/>
+                  <a:srgbClr val="475569"/>
                 </a:solidFill>
                 <a:latin typeface="Segoe UI"/>
               </a:defRPr>
@@ -13342,7 +13297,7 @@
               </a:spcAft>
               <a:defRPr sz="1600">
                 <a:solidFill>
-                  <a:srgbClr val="94A3B8"/>
+                  <a:srgbClr val="475569"/>
                 </a:solidFill>
                 <a:latin typeface="Segoe UI"/>
               </a:defRPr>
@@ -13367,7 +13322,7 @@
     <p:bg>
       <p:bgPr>
         <a:solidFill>
-          <a:srgbClr val="0F172A"/>
+          <a:srgbClr val="F1F5F9"/>
         </a:solidFill>
         <a:effectLst/>
       </p:bgPr>
@@ -13404,7 +13359,7 @@
             <a:pPr>
               <a:defRPr sz="3200" b="1">
                 <a:solidFill>
-                  <a:srgbClr val="38BDF8"/>
+                  <a:srgbClr val="4F46E5"/>
                 </a:solidFill>
                 <a:latin typeface="Segoe UI"/>
               </a:defRPr>
@@ -13443,7 +13398,7 @@
               </a:spcAft>
               <a:defRPr sz="1600">
                 <a:solidFill>
-                  <a:srgbClr val="94A3B8"/>
+                  <a:srgbClr val="475569"/>
                 </a:solidFill>
                 <a:latin typeface="Segoe UI"/>
               </a:defRPr>
@@ -13459,7 +13414,7 @@
               </a:spcAft>
               <a:defRPr sz="1600">
                 <a:solidFill>
-                  <a:srgbClr val="94A3B8"/>
+                  <a:srgbClr val="475569"/>
                 </a:solidFill>
                 <a:latin typeface="Segoe UI"/>
               </a:defRPr>
@@ -13475,7 +13430,7 @@
               </a:spcAft>
               <a:defRPr sz="1600">
                 <a:solidFill>
-                  <a:srgbClr val="94A3B8"/>
+                  <a:srgbClr val="475569"/>
                 </a:solidFill>
                 <a:latin typeface="Segoe UI"/>
               </a:defRPr>
@@ -13491,7 +13446,7 @@
               </a:spcAft>
               <a:defRPr sz="1600">
                 <a:solidFill>
-                  <a:srgbClr val="94A3B8"/>
+                  <a:srgbClr val="475569"/>
                 </a:solidFill>
                 <a:latin typeface="Segoe UI"/>
               </a:defRPr>
@@ -13507,7 +13462,7 @@
               </a:spcAft>
               <a:defRPr sz="1600">
                 <a:solidFill>
-                  <a:srgbClr val="94A3B8"/>
+                  <a:srgbClr val="475569"/>
                 </a:solidFill>
                 <a:latin typeface="Segoe UI"/>
               </a:defRPr>
@@ -13532,7 +13487,7 @@
     <p:bg>
       <p:bgPr>
         <a:solidFill>
-          <a:srgbClr val="0F172A"/>
+          <a:srgbClr val="F1F5F9"/>
         </a:solidFill>
         <a:effectLst/>
       </p:bgPr>
@@ -13569,7 +13524,7 @@
             <a:pPr>
               <a:defRPr sz="3200" b="1">
                 <a:solidFill>
-                  <a:srgbClr val="38BDF8"/>
+                  <a:srgbClr val="4F46E5"/>
                 </a:solidFill>
                 <a:latin typeface="Segoe UI"/>
               </a:defRPr>
@@ -13608,7 +13563,7 @@
               </a:spcAft>
               <a:defRPr sz="1600">
                 <a:solidFill>
-                  <a:srgbClr val="94A3B8"/>
+                  <a:srgbClr val="475569"/>
                 </a:solidFill>
                 <a:latin typeface="Segoe UI"/>
               </a:defRPr>
@@ -13624,7 +13579,7 @@
               </a:spcAft>
               <a:defRPr sz="1600">
                 <a:solidFill>
-                  <a:srgbClr val="94A3B8"/>
+                  <a:srgbClr val="475569"/>
                 </a:solidFill>
                 <a:latin typeface="Segoe UI"/>
               </a:defRPr>
@@ -13640,7 +13595,7 @@
               </a:spcAft>
               <a:defRPr sz="1600">
                 <a:solidFill>
-                  <a:srgbClr val="94A3B8"/>
+                  <a:srgbClr val="475569"/>
                 </a:solidFill>
                 <a:latin typeface="Segoe UI"/>
               </a:defRPr>
@@ -13656,7 +13611,7 @@
               </a:spcAft>
               <a:defRPr sz="1600">
                 <a:solidFill>
-                  <a:srgbClr val="94A3B8"/>
+                  <a:srgbClr val="475569"/>
                 </a:solidFill>
                 <a:latin typeface="Segoe UI"/>
               </a:defRPr>
@@ -13681,7 +13636,7 @@
     <p:bg>
       <p:bgPr>
         <a:solidFill>
-          <a:srgbClr val="0F172A"/>
+          <a:srgbClr val="F1F5F9"/>
         </a:solidFill>
         <a:effectLst/>
       </p:bgPr>
@@ -13718,7 +13673,7 @@
             <a:pPr>
               <a:defRPr sz="3200" b="1">
                 <a:solidFill>
-                  <a:srgbClr val="38BDF8"/>
+                  <a:srgbClr val="4F46E5"/>
                 </a:solidFill>
                 <a:latin typeface="Segoe UI"/>
               </a:defRPr>
@@ -13757,7 +13712,7 @@
               </a:spcAft>
               <a:defRPr sz="1600">
                 <a:solidFill>
-                  <a:srgbClr val="94A3B8"/>
+                  <a:srgbClr val="475569"/>
                 </a:solidFill>
                 <a:latin typeface="Segoe UI"/>
               </a:defRPr>
@@ -13773,7 +13728,7 @@
               </a:spcAft>
               <a:defRPr sz="1600">
                 <a:solidFill>
-                  <a:srgbClr val="94A3B8"/>
+                  <a:srgbClr val="475569"/>
                 </a:solidFill>
                 <a:latin typeface="Segoe UI"/>
               </a:defRPr>
@@ -13789,7 +13744,7 @@
               </a:spcAft>
               <a:defRPr sz="1600">
                 <a:solidFill>
-                  <a:srgbClr val="94A3B8"/>
+                  <a:srgbClr val="475569"/>
                 </a:solidFill>
                 <a:latin typeface="Segoe UI"/>
               </a:defRPr>
@@ -13805,7 +13760,7 @@
               </a:spcAft>
               <a:defRPr sz="1600">
                 <a:solidFill>
-                  <a:srgbClr val="94A3B8"/>
+                  <a:srgbClr val="475569"/>
                 </a:solidFill>
                 <a:latin typeface="Segoe UI"/>
               </a:defRPr>
@@ -13830,7 +13785,7 @@
     <p:bg>
       <p:bgPr>
         <a:solidFill>
-          <a:srgbClr val="0F172A"/>
+          <a:srgbClr val="F1F5F9"/>
         </a:solidFill>
         <a:effectLst/>
       </p:bgPr>
@@ -13867,7 +13822,7 @@
             <a:pPr>
               <a:defRPr sz="3200" b="1">
                 <a:solidFill>
-                  <a:srgbClr val="38BDF8"/>
+                  <a:srgbClr val="4F46E5"/>
                 </a:solidFill>
                 <a:latin typeface="Segoe UI"/>
               </a:defRPr>
@@ -13906,7 +13861,7 @@
               </a:spcAft>
               <a:defRPr sz="1600">
                 <a:solidFill>
-                  <a:srgbClr val="94A3B8"/>
+                  <a:srgbClr val="475569"/>
                 </a:solidFill>
                 <a:latin typeface="Segoe UI"/>
               </a:defRPr>
@@ -13922,7 +13877,7 @@
               </a:spcAft>
               <a:defRPr sz="1600">
                 <a:solidFill>
-                  <a:srgbClr val="94A3B8"/>
+                  <a:srgbClr val="475569"/>
                 </a:solidFill>
                 <a:latin typeface="Segoe UI"/>
               </a:defRPr>
@@ -13938,7 +13893,7 @@
               </a:spcAft>
               <a:defRPr sz="1600">
                 <a:solidFill>
-                  <a:srgbClr val="94A3B8"/>
+                  <a:srgbClr val="475569"/>
                 </a:solidFill>
                 <a:latin typeface="Segoe UI"/>
               </a:defRPr>
@@ -13954,7 +13909,7 @@
               </a:spcAft>
               <a:defRPr sz="1600">
                 <a:solidFill>
-                  <a:srgbClr val="94A3B8"/>
+                  <a:srgbClr val="475569"/>
                 </a:solidFill>
                 <a:latin typeface="Segoe UI"/>
               </a:defRPr>
@@ -13979,7 +13934,7 @@
     <p:bg>
       <p:bgPr>
         <a:solidFill>
-          <a:srgbClr val="0F172A"/>
+          <a:srgbClr val="F1F5F9"/>
         </a:solidFill>
         <a:effectLst/>
       </p:bgPr>
@@ -14016,7 +13971,7 @@
             <a:pPr>
               <a:defRPr sz="3200" b="1">
                 <a:solidFill>
-                  <a:srgbClr val="38BDF8"/>
+                  <a:srgbClr val="4F46E5"/>
                 </a:solidFill>
                 <a:latin typeface="Segoe UI"/>
               </a:defRPr>
@@ -14055,7 +14010,7 @@
               </a:spcAft>
               <a:defRPr sz="1600">
                 <a:solidFill>
-                  <a:srgbClr val="94A3B8"/>
+                  <a:srgbClr val="475569"/>
                 </a:solidFill>
                 <a:latin typeface="Segoe UI"/>
               </a:defRPr>
@@ -14071,7 +14026,7 @@
               </a:spcAft>
               <a:defRPr sz="1600">
                 <a:solidFill>
-                  <a:srgbClr val="94A3B8"/>
+                  <a:srgbClr val="475569"/>
                 </a:solidFill>
                 <a:latin typeface="Segoe UI"/>
               </a:defRPr>
@@ -14087,7 +14042,7 @@
               </a:spcAft>
               <a:defRPr sz="1600">
                 <a:solidFill>
-                  <a:srgbClr val="94A3B8"/>
+                  <a:srgbClr val="475569"/>
                 </a:solidFill>
                 <a:latin typeface="Segoe UI"/>
               </a:defRPr>
@@ -14103,7 +14058,7 @@
               </a:spcAft>
               <a:defRPr sz="1600">
                 <a:solidFill>
-                  <a:srgbClr val="94A3B8"/>
+                  <a:srgbClr val="475569"/>
                 </a:solidFill>
                 <a:latin typeface="Segoe UI"/>
               </a:defRPr>

</xml_diff>

<commit_message>
Integrate user's custom circuit background image into PPTX
</commit_message>
<xml_diff>
--- a/AI_Based_Document_Similarity_Duplicate_Detection_NLP_PBL.pptx
+++ b/AI_Based_Document_Similarity_Duplicate_Detection_NLP_PBL.pptx
@@ -3127,352 +3127,9 @@
         <p:nvPr/>
       </p:nvGrpSpPr>
       <p:grpSpPr/>
-      <p:sp>
-        <p:nvSpPr>
-          <p:cNvPr id="2" name="TextBox 1"/>
-          <p:cNvSpPr txBox="1"/>
-          <p:nvPr/>
-        </p:nvSpPr>
-        <p:spPr>
-          <a:xfrm>
-            <a:off x="685800" y="182880"/>
-            <a:ext cx="10817352" cy="1280160"/>
-          </a:xfrm>
-          <a:prstGeom prst="rect">
-            <a:avLst/>
-          </a:prstGeom>
-          <a:noFill/>
-        </p:spPr>
-        <p:txBody>
-          <a:bodyPr wrap="square">
-            <a:spAutoFit/>
-          </a:bodyPr>
-          <a:lstStyle/>
-          <a:p>
-            <a:pPr algn="ctr">
-              <a:defRPr sz="2800" b="1">
-                <a:solidFill>
-                  <a:srgbClr val="4F46E5"/>
-                </a:solidFill>
-                <a:latin typeface="Segoe UI"/>
-              </a:defRPr>
-            </a:pPr>
-            <a:r>
-              <a:t>AI-Based Document Similarity &amp; Duplicate Detection System Using NLP</a:t>
-            </a:r>
-          </a:p>
-          <a:p>
-            <a:pPr algn="ctr">
-              <a:spcBef>
-                <a:spcPts val="400"/>
-              </a:spcBef>
-              <a:defRPr sz="1600">
-                <a:solidFill>
-                  <a:srgbClr val="475569"/>
-                </a:solidFill>
-                <a:latin typeface="Segoe UI"/>
-              </a:defRPr>
-            </a:pPr>
-            <a:r>
-              <a:t>AI-Based Document Processing Using OCR, NLP and Similarity Analysis</a:t>
-            </a:r>
-            <a:br/>
-            <a:r>
-              <a:t>PBL Task 2</a:t>
-            </a:r>
-          </a:p>
-        </p:txBody>
-      </p:sp>
-      <p:sp>
-        <p:nvSpPr>
-          <p:cNvPr id="3" name="TextBox 2"/>
-          <p:cNvSpPr txBox="1"/>
-          <p:nvPr/>
-        </p:nvSpPr>
-        <p:spPr>
-          <a:xfrm>
-            <a:off x="685800" y="1645920"/>
-            <a:ext cx="10817352" cy="731520"/>
-          </a:xfrm>
-          <a:prstGeom prst="rect">
-            <a:avLst/>
-          </a:prstGeom>
-          <a:noFill/>
-        </p:spPr>
-        <p:txBody>
-          <a:bodyPr wrap="square">
-            <a:spAutoFit/>
-          </a:bodyPr>
-          <a:lstStyle/>
-          <a:p>
-            <a:pPr algn="ctr"/>
-            <a:r>
-              <a:rPr sz="1800" b="1">
-                <a:solidFill>
-                  <a:srgbClr val="4F46E5"/>
-                </a:solidFill>
-                <a:latin typeface="Segoe UI"/>
-              </a:rPr>
-              <a:t>Subject: </a:t>
-            </a:r>
-            <a:r>
-              <a:rPr sz="1800" b="1">
-                <a:solidFill>
-                  <a:srgbClr val="0F172A"/>
-                </a:solidFill>
-                <a:latin typeface="Segoe UI"/>
-              </a:rPr>
-              <a:t>Python for Data Science (BE05000231)</a:t>
-            </a:r>
-          </a:p>
-        </p:txBody>
-      </p:sp>
-      <p:sp>
-        <p:nvSpPr>
-          <p:cNvPr id="4" name="Rectangle 3"/>
-          <p:cNvSpPr/>
-          <p:nvPr/>
-        </p:nvSpPr>
-        <p:spPr>
-          <a:xfrm>
-            <a:off x="685800" y="2468880"/>
-            <a:ext cx="10817352" cy="3749039"/>
-          </a:xfrm>
-          <a:prstGeom prst="rect">
-            <a:avLst/>
-          </a:prstGeom>
-          <a:solidFill>
-            <a:srgbClr val="FFFFFF"/>
-          </a:solidFill>
-          <a:ln w="19050">
-            <a:solidFill>
-              <a:srgbClr val="475569"/>
-            </a:solidFill>
-          </a:ln>
-        </p:spPr>
-        <p:style>
-          <a:lnRef idx="1">
-            <a:schemeClr val="accent1"/>
-          </a:lnRef>
-          <a:fillRef idx="3">
-            <a:schemeClr val="accent1"/>
-          </a:fillRef>
-          <a:effectRef idx="2">
-            <a:schemeClr val="accent1"/>
-          </a:effectRef>
-          <a:fontRef idx="minor">
-            <a:schemeClr val="lt1"/>
-          </a:fontRef>
-        </p:style>
-        <p:txBody>
-          <a:bodyPr rtlCol="0" anchor="ctr"/>
-          <a:lstStyle/>
-          <a:p>
-            <a:pPr algn="ctr"/>
-          </a:p>
-        </p:txBody>
-      </p:sp>
-      <p:sp>
-        <p:nvSpPr>
-          <p:cNvPr id="5" name="TextBox 4"/>
-          <p:cNvSpPr txBox="1"/>
-          <p:nvPr/>
-        </p:nvSpPr>
-        <p:spPr>
-          <a:xfrm>
-            <a:off x="1097280" y="2651760"/>
-            <a:ext cx="4572000" cy="1005840"/>
-          </a:xfrm>
-          <a:prstGeom prst="rect">
-            <a:avLst/>
-          </a:prstGeom>
-          <a:noFill/>
-        </p:spPr>
-        <p:txBody>
-          <a:bodyPr wrap="square">
-            <a:spAutoFit/>
-          </a:bodyPr>
-          <a:lstStyle/>
-          <a:p>
-            <a:r>
-              <a:rPr b="1" sz="1700">
-                <a:solidFill>
-                  <a:srgbClr val="4F46E5"/>
-                </a:solidFill>
-                <a:latin typeface="Segoe UI"/>
-              </a:rPr>
-              <a:t>NAME 1: </a:t>
-            </a:r>
-            <a:r>
-              <a:rPr sz="1700">
-                <a:solidFill>
-                  <a:srgbClr val="0F172A"/>
-                </a:solidFill>
-                <a:latin typeface="Segoe UI"/>
-              </a:rPr>
-              <a:t>Nimavat Jaydeep M.</a:t>
-            </a:r>
-          </a:p>
-          <a:p>
-            <a:pPr>
-              <a:spcBef>
-                <a:spcPts val="400"/>
-              </a:spcBef>
-            </a:pPr>
-            <a:r>
-              <a:rPr b="1" sz="1700">
-                <a:solidFill>
-                  <a:srgbClr val="4F46E5"/>
-                </a:solidFill>
-                <a:latin typeface="Segoe UI"/>
-              </a:rPr>
-              <a:t>ENROLLMENT 1: </a:t>
-            </a:r>
-            <a:r>
-              <a:rPr sz="1700">
-                <a:solidFill>
-                  <a:srgbClr val="0F172A"/>
-                </a:solidFill>
-                <a:latin typeface="Segoe UI"/>
-              </a:rPr>
-              <a:t>250043107032</a:t>
-            </a:r>
-          </a:p>
-        </p:txBody>
-      </p:sp>
-      <p:sp>
-        <p:nvSpPr>
-          <p:cNvPr id="6" name="TextBox 5"/>
-          <p:cNvSpPr txBox="1"/>
-          <p:nvPr/>
-        </p:nvSpPr>
-        <p:spPr>
-          <a:xfrm>
-            <a:off x="6217920" y="2651760"/>
-            <a:ext cx="4572000" cy="1005840"/>
-          </a:xfrm>
-          <a:prstGeom prst="rect">
-            <a:avLst/>
-          </a:prstGeom>
-          <a:noFill/>
-        </p:spPr>
-        <p:txBody>
-          <a:bodyPr wrap="square">
-            <a:spAutoFit/>
-          </a:bodyPr>
-          <a:lstStyle/>
-          <a:p>
-            <a:r>
-              <a:rPr b="1" sz="1700">
-                <a:solidFill>
-                  <a:srgbClr val="4F46E5"/>
-                </a:solidFill>
-                <a:latin typeface="Segoe UI"/>
-              </a:rPr>
-              <a:t>NAME 2: </a:t>
-            </a:r>
-            <a:r>
-              <a:rPr sz="1700">
-                <a:solidFill>
-                  <a:srgbClr val="0F172A"/>
-                </a:solidFill>
-                <a:latin typeface="Segoe UI"/>
-              </a:rPr>
-              <a:t>Upadhyay Hitarth S.</a:t>
-            </a:r>
-          </a:p>
-          <a:p>
-            <a:pPr>
-              <a:spcBef>
-                <a:spcPts val="400"/>
-              </a:spcBef>
-            </a:pPr>
-            <a:r>
-              <a:rPr b="1" sz="1700">
-                <a:solidFill>
-                  <a:srgbClr val="4F46E5"/>
-                </a:solidFill>
-                <a:latin typeface="Segoe UI"/>
-              </a:rPr>
-              <a:t>ENROLLMENT 2: </a:t>
-            </a:r>
-            <a:r>
-              <a:rPr sz="1700">
-                <a:solidFill>
-                  <a:srgbClr val="0F172A"/>
-                </a:solidFill>
-                <a:latin typeface="Segoe UI"/>
-              </a:rPr>
-              <a:t>250043107050</a:t>
-            </a:r>
-          </a:p>
-        </p:txBody>
-      </p:sp>
-      <p:sp>
-        <p:nvSpPr>
-          <p:cNvPr id="7" name="TextBox 6"/>
-          <p:cNvSpPr txBox="1"/>
-          <p:nvPr/>
-        </p:nvSpPr>
-        <p:spPr>
-          <a:xfrm>
-            <a:off x="1097280" y="3931920"/>
-            <a:ext cx="9966960" cy="548640"/>
-          </a:xfrm>
-          <a:prstGeom prst="rect">
-            <a:avLst/>
-          </a:prstGeom>
-          <a:noFill/>
-        </p:spPr>
-        <p:txBody>
-          <a:bodyPr wrap="none">
-            <a:spAutoFit/>
-          </a:bodyPr>
-          <a:lstStyle/>
-          <a:p>
-            <a:pPr algn="ctr"/>
-            <a:r>
-              <a:rPr b="1" sz="1700">
-                <a:solidFill>
-                  <a:srgbClr val="4F46E5"/>
-                </a:solidFill>
-                <a:latin typeface="Segoe UI"/>
-              </a:rPr>
-              <a:t>BRANCH: </a:t>
-            </a:r>
-            <a:r>
-              <a:rPr sz="1700">
-                <a:solidFill>
-                  <a:srgbClr val="0F172A"/>
-                </a:solidFill>
-                <a:latin typeface="Segoe UI"/>
-              </a:rPr>
-              <a:t>Computer Engineering     |     </a:t>
-            </a:r>
-            <a:r>
-              <a:rPr b="1" sz="1700">
-                <a:solidFill>
-                  <a:srgbClr val="4F46E5"/>
-                </a:solidFill>
-                <a:latin typeface="Segoe UI"/>
-              </a:rPr>
-              <a:t>SEMESTER: </a:t>
-            </a:r>
-            <a:r>
-              <a:rPr sz="1700">
-                <a:solidFill>
-                  <a:srgbClr val="0F172A"/>
-                </a:solidFill>
-                <a:latin typeface="Segoe UI"/>
-              </a:rPr>
-              <a:t>5th</a:t>
-            </a:r>
-          </a:p>
-        </p:txBody>
-      </p:sp>
       <p:pic>
         <p:nvPicPr>
-          <p:cNvPr id="8" name="Picture 7" descr="college_logo.png"/>
+          <p:cNvPr id="2" name="Picture 1" descr="college_logo.png"/>
           <p:cNvPicPr>
             <a:picLocks noChangeAspect="1"/>
           </p:cNvPicPr>
@@ -3486,14 +3143,222 @@
         </p:blipFill>
         <p:spPr>
           <a:xfrm>
-            <a:off x="3438144" y="4663440"/>
-            <a:ext cx="5303520" cy="1097280"/>
+            <a:off x="7616952" y="365760"/>
+            <a:ext cx="3931920" cy="822960"/>
           </a:xfrm>
           <a:prstGeom prst="rect">
             <a:avLst/>
           </a:prstGeom>
         </p:spPr>
       </p:pic>
+      <p:sp>
+        <p:nvSpPr>
+          <p:cNvPr id="3" name="TextBox 2"/>
+          <p:cNvSpPr txBox="1"/>
+          <p:nvPr/>
+        </p:nvSpPr>
+        <p:spPr>
+          <a:xfrm>
+            <a:off x="685800" y="2011680"/>
+            <a:ext cx="10817352" cy="1645920"/>
+          </a:xfrm>
+          <a:prstGeom prst="rect">
+            <a:avLst/>
+          </a:prstGeom>
+          <a:noFill/>
+        </p:spPr>
+        <p:txBody>
+          <a:bodyPr wrap="square" lIns="0" tIns="0" rIns="0" bIns="0">
+            <a:spAutoFit/>
+          </a:bodyPr>
+          <a:lstStyle/>
+          <a:p>
+            <a:pPr algn="l">
+              <a:defRPr sz="3600" b="1">
+                <a:solidFill>
+                  <a:srgbClr val="1E3A8A"/>
+                </a:solidFill>
+                <a:latin typeface="Segoe UI"/>
+              </a:defRPr>
+            </a:pPr>
+            <a:r>
+              <a:t>AI-Based Document Similarity &amp; Duplicate</a:t>
+            </a:r>
+            <a:br/>
+            <a:r>
+              <a:t>Detection System Using NLP</a:t>
+            </a:r>
+          </a:p>
+          <a:p>
+            <a:pPr algn="l">
+              <a:spcBef>
+                <a:spcPts val="800"/>
+              </a:spcBef>
+              <a:defRPr sz="2000" b="1">
+                <a:solidFill>
+                  <a:srgbClr val="0EA5E9"/>
+                </a:solidFill>
+                <a:latin typeface="Segoe UI"/>
+              </a:defRPr>
+            </a:pPr>
+            <a:r>
+              <a:t>SUBJECT: PYTHON FOR DATA SCIENCE (BE05000231)</a:t>
+            </a:r>
+          </a:p>
+        </p:txBody>
+      </p:sp>
+      <p:sp>
+        <p:nvSpPr>
+          <p:cNvPr id="4" name="TextBox 3"/>
+          <p:cNvSpPr txBox="1"/>
+          <p:nvPr/>
+        </p:nvSpPr>
+        <p:spPr>
+          <a:xfrm>
+            <a:off x="685800" y="4389120"/>
+            <a:ext cx="5029200" cy="1828800"/>
+          </a:xfrm>
+          <a:prstGeom prst="rect">
+            <a:avLst/>
+          </a:prstGeom>
+          <a:noFill/>
+        </p:spPr>
+        <p:txBody>
+          <a:bodyPr wrap="square" lIns="0" tIns="0" rIns="0" bIns="0">
+            <a:spAutoFit/>
+          </a:bodyPr>
+          <a:lstStyle/>
+          <a:p>
+            <a:pPr>
+              <a:defRPr sz="1700" b="1">
+                <a:solidFill>
+                  <a:srgbClr val="0F172A"/>
+                </a:solidFill>
+                <a:latin typeface="Segoe UI"/>
+              </a:defRPr>
+            </a:pPr>
+            <a:r>
+              <a:t>Presented By:</a:t>
+            </a:r>
+          </a:p>
+          <a:p>
+            <a:pPr>
+              <a:spcBef>
+                <a:spcPts val="600"/>
+              </a:spcBef>
+              <a:defRPr sz="1600">
+                <a:solidFill>
+                  <a:srgbClr val="475569"/>
+                </a:solidFill>
+                <a:latin typeface="Segoe UI"/>
+              </a:defRPr>
+            </a:pPr>
+            <a:r>
+              <a:t>Nimavat Jaydeep M.</a:t>
+            </a:r>
+            <a:br/>
+            <a:r>
+              <a:t>Enrollment: 250043107032</a:t>
+            </a:r>
+          </a:p>
+          <a:p>
+            <a:pPr>
+              <a:spcBef>
+                <a:spcPts val="600"/>
+              </a:spcBef>
+              <a:defRPr sz="1600">
+                <a:solidFill>
+                  <a:srgbClr val="475569"/>
+                </a:solidFill>
+                <a:latin typeface="Segoe UI"/>
+              </a:defRPr>
+            </a:pPr>
+            <a:r>
+              <a:t>Upadhyay Hitarth S.</a:t>
+            </a:r>
+            <a:br/>
+            <a:r>
+              <a:t>Enrollment: 250043107050</a:t>
+            </a:r>
+          </a:p>
+        </p:txBody>
+      </p:sp>
+      <p:sp>
+        <p:nvSpPr>
+          <p:cNvPr id="5" name="TextBox 4"/>
+          <p:cNvSpPr txBox="1"/>
+          <p:nvPr/>
+        </p:nvSpPr>
+        <p:spPr>
+          <a:xfrm>
+            <a:off x="6629400" y="4389120"/>
+            <a:ext cx="4572000" cy="1828800"/>
+          </a:xfrm>
+          <a:prstGeom prst="rect">
+            <a:avLst/>
+          </a:prstGeom>
+          <a:noFill/>
+        </p:spPr>
+        <p:txBody>
+          <a:bodyPr wrap="square" lIns="0" tIns="0" rIns="0" bIns="0">
+            <a:spAutoFit/>
+          </a:bodyPr>
+          <a:lstStyle/>
+          <a:p>
+            <a:pPr>
+              <a:defRPr sz="1700" b="1">
+                <a:solidFill>
+                  <a:srgbClr val="0F172A"/>
+                </a:solidFill>
+                <a:latin typeface="Segoe UI"/>
+              </a:defRPr>
+            </a:pPr>
+            <a:r>
+              <a:t>Branch &amp; Semester:</a:t>
+            </a:r>
+          </a:p>
+          <a:p>
+            <a:pPr>
+              <a:spcBef>
+                <a:spcPts val="600"/>
+              </a:spcBef>
+              <a:defRPr sz="1600">
+                <a:solidFill>
+                  <a:srgbClr val="475569"/>
+                </a:solidFill>
+                <a:latin typeface="Segoe UI"/>
+              </a:defRPr>
+            </a:pPr>
+            <a:r>
+              <a:t>Computer Engineering (CE)</a:t>
+            </a:r>
+            <a:br/>
+            <a:r>
+              <a:t>Semester: 5</a:t>
+            </a:r>
+          </a:p>
+          <a:p>
+            <a:pPr>
+              <a:spcBef>
+                <a:spcPts val="600"/>
+              </a:spcBef>
+              <a:defRPr sz="1600">
+                <a:solidFill>
+                  <a:srgbClr val="475569"/>
+                </a:solidFill>
+                <a:latin typeface="Segoe UI"/>
+              </a:defRPr>
+            </a:pPr>
+            <a:r>
+              <a:t>College:</a:t>
+            </a:r>
+            <a:br/>
+            <a:r>
+              <a:t>B H Gardi College Of Engineering &amp; Technology</a:t>
+            </a:r>
+          </a:p>
+        </p:txBody>
+      </p:sp>
     </p:spTree>
   </p:cSld>
   <p:clrMapOvr>
@@ -3528,8 +3393,8 @@
         </p:nvSpPr>
         <p:spPr>
           <a:xfrm>
-            <a:off x="685800" y="457200"/>
-            <a:ext cx="10817352" cy="731520"/>
+            <a:off x="685800" y="365760"/>
+            <a:ext cx="7772400" cy="731520"/>
           </a:xfrm>
           <a:prstGeom prst="rect">
             <a:avLst/>
@@ -3556,9 +3421,33 @@
           </a:p>
         </p:txBody>
       </p:sp>
+      <p:pic>
+        <p:nvPicPr>
+          <p:cNvPr id="3" name="Picture 2" descr="college_logo.png"/>
+          <p:cNvPicPr>
+            <a:picLocks noChangeAspect="1"/>
+          </p:cNvPicPr>
+          <p:nvPr/>
+        </p:nvPicPr>
+        <p:blipFill>
+          <a:blip r:embed="rId2"/>
+          <a:stretch>
+            <a:fillRect/>
+          </a:stretch>
+        </p:blipFill>
+        <p:spPr>
+          <a:xfrm>
+            <a:off x="8412480" y="274320"/>
+            <a:ext cx="3108960" cy="685800"/>
+          </a:xfrm>
+          <a:prstGeom prst="rect">
+            <a:avLst/>
+          </a:prstGeom>
+        </p:spPr>
+      </p:pic>
       <p:sp>
         <p:nvSpPr>
-          <p:cNvPr id="3" name="TextBox 2"/>
+          <p:cNvPr id="4" name="TextBox 3"/>
           <p:cNvSpPr txBox="1"/>
           <p:nvPr/>
         </p:nvSpPr>
@@ -3693,8 +3582,8 @@
         </p:nvSpPr>
         <p:spPr>
           <a:xfrm>
-            <a:off x="685800" y="457200"/>
-            <a:ext cx="10817352" cy="731520"/>
+            <a:off x="685800" y="365760"/>
+            <a:ext cx="7772400" cy="731520"/>
           </a:xfrm>
           <a:prstGeom prst="rect">
             <a:avLst/>
@@ -3721,9 +3610,33 @@
           </a:p>
         </p:txBody>
       </p:sp>
+      <p:pic>
+        <p:nvPicPr>
+          <p:cNvPr id="3" name="Picture 2" descr="college_logo.png"/>
+          <p:cNvPicPr>
+            <a:picLocks noChangeAspect="1"/>
+          </p:cNvPicPr>
+          <p:nvPr/>
+        </p:nvPicPr>
+        <p:blipFill>
+          <a:blip r:embed="rId2"/>
+          <a:stretch>
+            <a:fillRect/>
+          </a:stretch>
+        </p:blipFill>
+        <p:spPr>
+          <a:xfrm>
+            <a:off x="8412480" y="274320"/>
+            <a:ext cx="3108960" cy="685800"/>
+          </a:xfrm>
+          <a:prstGeom prst="rect">
+            <a:avLst/>
+          </a:prstGeom>
+        </p:spPr>
+      </p:pic>
       <p:sp>
         <p:nvSpPr>
-          <p:cNvPr id="3" name="TextBox 2"/>
+          <p:cNvPr id="4" name="TextBox 3"/>
           <p:cNvSpPr txBox="1"/>
           <p:nvPr/>
         </p:nvSpPr>
@@ -3842,8 +3755,8 @@
         </p:nvSpPr>
         <p:spPr>
           <a:xfrm>
-            <a:off x="685800" y="457200"/>
-            <a:ext cx="10817352" cy="731520"/>
+            <a:off x="685800" y="365760"/>
+            <a:ext cx="7772400" cy="731520"/>
           </a:xfrm>
           <a:prstGeom prst="rect">
             <a:avLst/>
@@ -3870,9 +3783,33 @@
           </a:p>
         </p:txBody>
       </p:sp>
+      <p:pic>
+        <p:nvPicPr>
+          <p:cNvPr id="3" name="Picture 2" descr="college_logo.png"/>
+          <p:cNvPicPr>
+            <a:picLocks noChangeAspect="1"/>
+          </p:cNvPicPr>
+          <p:nvPr/>
+        </p:nvPicPr>
+        <p:blipFill>
+          <a:blip r:embed="rId2"/>
+          <a:stretch>
+            <a:fillRect/>
+          </a:stretch>
+        </p:blipFill>
+        <p:spPr>
+          <a:xfrm>
+            <a:off x="8412480" y="274320"/>
+            <a:ext cx="3108960" cy="685800"/>
+          </a:xfrm>
+          <a:prstGeom prst="rect">
+            <a:avLst/>
+          </a:prstGeom>
+        </p:spPr>
+      </p:pic>
       <p:sp>
         <p:nvSpPr>
-          <p:cNvPr id="3" name="TextBox 2"/>
+          <p:cNvPr id="4" name="TextBox 3"/>
           <p:cNvSpPr txBox="1"/>
           <p:nvPr/>
         </p:nvSpPr>
@@ -4007,8 +3944,8 @@
         </p:nvSpPr>
         <p:spPr>
           <a:xfrm>
-            <a:off x="685800" y="457200"/>
-            <a:ext cx="10817352" cy="731520"/>
+            <a:off x="685800" y="365760"/>
+            <a:ext cx="7772400" cy="731520"/>
           </a:xfrm>
           <a:prstGeom prst="rect">
             <a:avLst/>
@@ -4035,9 +3972,33 @@
           </a:p>
         </p:txBody>
       </p:sp>
+      <p:pic>
+        <p:nvPicPr>
+          <p:cNvPr id="3" name="Picture 2" descr="college_logo.png"/>
+          <p:cNvPicPr>
+            <a:picLocks noChangeAspect="1"/>
+          </p:cNvPicPr>
+          <p:nvPr/>
+        </p:nvPicPr>
+        <p:blipFill>
+          <a:blip r:embed="rId2"/>
+          <a:stretch>
+            <a:fillRect/>
+          </a:stretch>
+        </p:blipFill>
+        <p:spPr>
+          <a:xfrm>
+            <a:off x="8412480" y="274320"/>
+            <a:ext cx="3108960" cy="685800"/>
+          </a:xfrm>
+          <a:prstGeom prst="rect">
+            <a:avLst/>
+          </a:prstGeom>
+        </p:spPr>
+      </p:pic>
       <p:sp>
         <p:nvSpPr>
-          <p:cNvPr id="3" name="TextBox 2"/>
+          <p:cNvPr id="4" name="TextBox 3"/>
           <p:cNvSpPr txBox="1"/>
           <p:nvPr/>
         </p:nvSpPr>
@@ -4172,8 +4133,8 @@
         </p:nvSpPr>
         <p:spPr>
           <a:xfrm>
-            <a:off x="685800" y="457200"/>
-            <a:ext cx="10817352" cy="731520"/>
+            <a:off x="685800" y="365760"/>
+            <a:ext cx="7772400" cy="731520"/>
           </a:xfrm>
           <a:prstGeom prst="rect">
             <a:avLst/>
@@ -4200,9 +4161,33 @@
           </a:p>
         </p:txBody>
       </p:sp>
+      <p:pic>
+        <p:nvPicPr>
+          <p:cNvPr id="3" name="Picture 2" descr="college_logo.png"/>
+          <p:cNvPicPr>
+            <a:picLocks noChangeAspect="1"/>
+          </p:cNvPicPr>
+          <p:nvPr/>
+        </p:nvPicPr>
+        <p:blipFill>
+          <a:blip r:embed="rId2"/>
+          <a:stretch>
+            <a:fillRect/>
+          </a:stretch>
+        </p:blipFill>
+        <p:spPr>
+          <a:xfrm>
+            <a:off x="8412480" y="274320"/>
+            <a:ext cx="3108960" cy="685800"/>
+          </a:xfrm>
+          <a:prstGeom prst="rect">
+            <a:avLst/>
+          </a:prstGeom>
+        </p:spPr>
+      </p:pic>
       <p:sp>
         <p:nvSpPr>
-          <p:cNvPr id="3" name="TextBox 2"/>
+          <p:cNvPr id="4" name="TextBox 3"/>
           <p:cNvSpPr txBox="1"/>
           <p:nvPr/>
         </p:nvSpPr>
@@ -4305,14 +4290,14 @@
       </p:sp>
       <p:pic>
         <p:nvPicPr>
-          <p:cNvPr id="4" name="Picture 3" descr="system_workflow_diagram.jpg"/>
+          <p:cNvPr id="5" name="Picture 4" descr="system_workflow_diagram.jpg"/>
           <p:cNvPicPr>
             <a:picLocks noChangeAspect="1"/>
           </p:cNvPicPr>
           <p:nvPr/>
         </p:nvPicPr>
         <p:blipFill>
-          <a:blip r:embed="rId2"/>
+          <a:blip r:embed="rId3"/>
           <a:stretch>
             <a:fillRect/>
           </a:stretch>
@@ -4361,8 +4346,8 @@
         </p:nvSpPr>
         <p:spPr>
           <a:xfrm>
-            <a:off x="685800" y="457200"/>
-            <a:ext cx="10817352" cy="731520"/>
+            <a:off x="685800" y="365760"/>
+            <a:ext cx="7772400" cy="731520"/>
           </a:xfrm>
           <a:prstGeom prst="rect">
             <a:avLst/>
@@ -4389,9 +4374,33 @@
           </a:p>
         </p:txBody>
       </p:sp>
+      <p:pic>
+        <p:nvPicPr>
+          <p:cNvPr id="3" name="Picture 2" descr="college_logo.png"/>
+          <p:cNvPicPr>
+            <a:picLocks noChangeAspect="1"/>
+          </p:cNvPicPr>
+          <p:nvPr/>
+        </p:nvPicPr>
+        <p:blipFill>
+          <a:blip r:embed="rId2"/>
+          <a:stretch>
+            <a:fillRect/>
+          </a:stretch>
+        </p:blipFill>
+        <p:spPr>
+          <a:xfrm>
+            <a:off x="8412480" y="274320"/>
+            <a:ext cx="3108960" cy="685800"/>
+          </a:xfrm>
+          <a:prstGeom prst="rect">
+            <a:avLst/>
+          </a:prstGeom>
+        </p:spPr>
+      </p:pic>
       <p:sp>
         <p:nvSpPr>
-          <p:cNvPr id="3" name="TextBox 2"/>
+          <p:cNvPr id="4" name="TextBox 3"/>
           <p:cNvSpPr txBox="1"/>
           <p:nvPr/>
         </p:nvSpPr>
@@ -4510,8 +4519,8 @@
         </p:nvSpPr>
         <p:spPr>
           <a:xfrm>
-            <a:off x="685800" y="457200"/>
-            <a:ext cx="10817352" cy="731520"/>
+            <a:off x="685800" y="365760"/>
+            <a:ext cx="7772400" cy="731520"/>
           </a:xfrm>
           <a:prstGeom prst="rect">
             <a:avLst/>
@@ -4538,9 +4547,33 @@
           </a:p>
         </p:txBody>
       </p:sp>
+      <p:pic>
+        <p:nvPicPr>
+          <p:cNvPr id="3" name="Picture 2" descr="college_logo.png"/>
+          <p:cNvPicPr>
+            <a:picLocks noChangeAspect="1"/>
+          </p:cNvPicPr>
+          <p:nvPr/>
+        </p:nvPicPr>
+        <p:blipFill>
+          <a:blip r:embed="rId2"/>
+          <a:stretch>
+            <a:fillRect/>
+          </a:stretch>
+        </p:blipFill>
+        <p:spPr>
+          <a:xfrm>
+            <a:off x="8412480" y="274320"/>
+            <a:ext cx="3108960" cy="685800"/>
+          </a:xfrm>
+          <a:prstGeom prst="rect">
+            <a:avLst/>
+          </a:prstGeom>
+        </p:spPr>
+      </p:pic>
       <p:sp>
         <p:nvSpPr>
-          <p:cNvPr id="3" name="TextBox 2"/>
+          <p:cNvPr id="4" name="TextBox 3"/>
           <p:cNvSpPr txBox="1"/>
           <p:nvPr/>
         </p:nvSpPr>
@@ -4659,8 +4692,8 @@
         </p:nvSpPr>
         <p:spPr>
           <a:xfrm>
-            <a:off x="685800" y="457200"/>
-            <a:ext cx="10817352" cy="731520"/>
+            <a:off x="685800" y="365760"/>
+            <a:ext cx="7772400" cy="731520"/>
           </a:xfrm>
           <a:prstGeom prst="rect">
             <a:avLst/>
@@ -4687,9 +4720,33 @@
           </a:p>
         </p:txBody>
       </p:sp>
+      <p:pic>
+        <p:nvPicPr>
+          <p:cNvPr id="3" name="Picture 2" descr="college_logo.png"/>
+          <p:cNvPicPr>
+            <a:picLocks noChangeAspect="1"/>
+          </p:cNvPicPr>
+          <p:nvPr/>
+        </p:nvPicPr>
+        <p:blipFill>
+          <a:blip r:embed="rId2"/>
+          <a:stretch>
+            <a:fillRect/>
+          </a:stretch>
+        </p:blipFill>
+        <p:spPr>
+          <a:xfrm>
+            <a:off x="8412480" y="274320"/>
+            <a:ext cx="3108960" cy="685800"/>
+          </a:xfrm>
+          <a:prstGeom prst="rect">
+            <a:avLst/>
+          </a:prstGeom>
+        </p:spPr>
+      </p:pic>
       <p:sp>
         <p:nvSpPr>
-          <p:cNvPr id="3" name="TextBox 2"/>
+          <p:cNvPr id="4" name="TextBox 3"/>
           <p:cNvSpPr txBox="1"/>
           <p:nvPr/>
         </p:nvSpPr>
@@ -4808,8 +4865,8 @@
         </p:nvSpPr>
         <p:spPr>
           <a:xfrm>
-            <a:off x="685800" y="457200"/>
-            <a:ext cx="10817352" cy="731520"/>
+            <a:off x="685800" y="365760"/>
+            <a:ext cx="7772400" cy="731520"/>
           </a:xfrm>
           <a:prstGeom prst="rect">
             <a:avLst/>
@@ -4836,9 +4893,33 @@
           </a:p>
         </p:txBody>
       </p:sp>
+      <p:pic>
+        <p:nvPicPr>
+          <p:cNvPr id="3" name="Picture 2" descr="college_logo.png"/>
+          <p:cNvPicPr>
+            <a:picLocks noChangeAspect="1"/>
+          </p:cNvPicPr>
+          <p:nvPr/>
+        </p:nvPicPr>
+        <p:blipFill>
+          <a:blip r:embed="rId2"/>
+          <a:stretch>
+            <a:fillRect/>
+          </a:stretch>
+        </p:blipFill>
+        <p:spPr>
+          <a:xfrm>
+            <a:off x="8412480" y="274320"/>
+            <a:ext cx="3108960" cy="685800"/>
+          </a:xfrm>
+          <a:prstGeom prst="rect">
+            <a:avLst/>
+          </a:prstGeom>
+        </p:spPr>
+      </p:pic>
       <p:sp>
         <p:nvSpPr>
-          <p:cNvPr id="3" name="TextBox 2"/>
+          <p:cNvPr id="4" name="TextBox 3"/>
           <p:cNvSpPr txBox="1"/>
           <p:nvPr/>
         </p:nvSpPr>
@@ -4957,8 +5038,8 @@
         </p:nvSpPr>
         <p:spPr>
           <a:xfrm>
-            <a:off x="685800" y="457200"/>
-            <a:ext cx="10817352" cy="731520"/>
+            <a:off x="685800" y="365760"/>
+            <a:ext cx="7772400" cy="731520"/>
           </a:xfrm>
           <a:prstGeom prst="rect">
             <a:avLst/>
@@ -4985,9 +5066,33 @@
           </a:p>
         </p:txBody>
       </p:sp>
+      <p:pic>
+        <p:nvPicPr>
+          <p:cNvPr id="3" name="Picture 2" descr="college_logo.png"/>
+          <p:cNvPicPr>
+            <a:picLocks noChangeAspect="1"/>
+          </p:cNvPicPr>
+          <p:nvPr/>
+        </p:nvPicPr>
+        <p:blipFill>
+          <a:blip r:embed="rId2"/>
+          <a:stretch>
+            <a:fillRect/>
+          </a:stretch>
+        </p:blipFill>
+        <p:spPr>
+          <a:xfrm>
+            <a:off x="8412480" y="274320"/>
+            <a:ext cx="3108960" cy="685800"/>
+          </a:xfrm>
+          <a:prstGeom prst="rect">
+            <a:avLst/>
+          </a:prstGeom>
+        </p:spPr>
+      </p:pic>
       <p:sp>
         <p:nvSpPr>
-          <p:cNvPr id="3" name="TextBox 2"/>
+          <p:cNvPr id="4" name="TextBox 3"/>
           <p:cNvSpPr txBox="1"/>
           <p:nvPr/>
         </p:nvSpPr>
@@ -5090,8 +5195,8 @@
         </p:nvSpPr>
         <p:spPr>
           <a:xfrm>
-            <a:off x="685800" y="457200"/>
-            <a:ext cx="10817352" cy="731520"/>
+            <a:off x="685800" y="365760"/>
+            <a:ext cx="7772400" cy="731520"/>
           </a:xfrm>
           <a:prstGeom prst="rect">
             <a:avLst/>
@@ -5118,9 +5223,33 @@
           </a:p>
         </p:txBody>
       </p:sp>
+      <p:pic>
+        <p:nvPicPr>
+          <p:cNvPr id="3" name="Picture 2" descr="college_logo.png"/>
+          <p:cNvPicPr>
+            <a:picLocks noChangeAspect="1"/>
+          </p:cNvPicPr>
+          <p:nvPr/>
+        </p:nvPicPr>
+        <p:blipFill>
+          <a:blip r:embed="rId2"/>
+          <a:stretch>
+            <a:fillRect/>
+          </a:stretch>
+        </p:blipFill>
+        <p:spPr>
+          <a:xfrm>
+            <a:off x="8412480" y="274320"/>
+            <a:ext cx="3108960" cy="685800"/>
+          </a:xfrm>
+          <a:prstGeom prst="rect">
+            <a:avLst/>
+          </a:prstGeom>
+        </p:spPr>
+      </p:pic>
       <p:sp>
         <p:nvSpPr>
-          <p:cNvPr id="3" name="TextBox 2"/>
+          <p:cNvPr id="4" name="TextBox 3"/>
           <p:cNvSpPr txBox="1"/>
           <p:nvPr/>
         </p:nvSpPr>
@@ -5255,8 +5384,8 @@
         </p:nvSpPr>
         <p:spPr>
           <a:xfrm>
-            <a:off x="685800" y="457200"/>
-            <a:ext cx="10817352" cy="731520"/>
+            <a:off x="685800" y="365760"/>
+            <a:ext cx="7772400" cy="731520"/>
           </a:xfrm>
           <a:prstGeom prst="rect">
             <a:avLst/>
@@ -5283,9 +5412,33 @@
           </a:p>
         </p:txBody>
       </p:sp>
+      <p:pic>
+        <p:nvPicPr>
+          <p:cNvPr id="3" name="Picture 2" descr="college_logo.png"/>
+          <p:cNvPicPr>
+            <a:picLocks noChangeAspect="1"/>
+          </p:cNvPicPr>
+          <p:nvPr/>
+        </p:nvPicPr>
+        <p:blipFill>
+          <a:blip r:embed="rId2"/>
+          <a:stretch>
+            <a:fillRect/>
+          </a:stretch>
+        </p:blipFill>
+        <p:spPr>
+          <a:xfrm>
+            <a:off x="8412480" y="274320"/>
+            <a:ext cx="3108960" cy="685800"/>
+          </a:xfrm>
+          <a:prstGeom prst="rect">
+            <a:avLst/>
+          </a:prstGeom>
+        </p:spPr>
+      </p:pic>
       <p:sp>
         <p:nvSpPr>
-          <p:cNvPr id="3" name="TextBox 2"/>
+          <p:cNvPr id="4" name="TextBox 3"/>
           <p:cNvSpPr txBox="1"/>
           <p:nvPr/>
         </p:nvSpPr>
@@ -5404,8 +5557,8 @@
         </p:nvSpPr>
         <p:spPr>
           <a:xfrm>
-            <a:off x="685800" y="457200"/>
-            <a:ext cx="10817352" cy="731520"/>
+            <a:off x="685800" y="365760"/>
+            <a:ext cx="7772400" cy="731520"/>
           </a:xfrm>
           <a:prstGeom prst="rect">
             <a:avLst/>
@@ -5432,9 +5585,33 @@
           </a:p>
         </p:txBody>
       </p:sp>
+      <p:pic>
+        <p:nvPicPr>
+          <p:cNvPr id="3" name="Picture 2" descr="college_logo.png"/>
+          <p:cNvPicPr>
+            <a:picLocks noChangeAspect="1"/>
+          </p:cNvPicPr>
+          <p:nvPr/>
+        </p:nvPicPr>
+        <p:blipFill>
+          <a:blip r:embed="rId2"/>
+          <a:stretch>
+            <a:fillRect/>
+          </a:stretch>
+        </p:blipFill>
+        <p:spPr>
+          <a:xfrm>
+            <a:off x="8412480" y="274320"/>
+            <a:ext cx="3108960" cy="685800"/>
+          </a:xfrm>
+          <a:prstGeom prst="rect">
+            <a:avLst/>
+          </a:prstGeom>
+        </p:spPr>
+      </p:pic>
       <p:sp>
         <p:nvSpPr>
-          <p:cNvPr id="3" name="TextBox 2"/>
+          <p:cNvPr id="4" name="TextBox 3"/>
           <p:cNvSpPr txBox="1"/>
           <p:nvPr/>
         </p:nvSpPr>
@@ -5537,7 +5714,7 @@
       </p:sp>
       <p:sp>
         <p:nvSpPr>
-          <p:cNvPr id="4" name="Rectangle 3"/>
+          <p:cNvPr id="5" name="Rectangle 4"/>
           <p:cNvSpPr/>
           <p:nvPr/>
         </p:nvSpPr>
@@ -6885,8 +7062,8 @@
         </p:nvSpPr>
         <p:spPr>
           <a:xfrm>
-            <a:off x="685800" y="457200"/>
-            <a:ext cx="10817352" cy="731520"/>
+            <a:off x="685800" y="365760"/>
+            <a:ext cx="7772400" cy="731520"/>
           </a:xfrm>
           <a:prstGeom prst="rect">
             <a:avLst/>
@@ -6913,9 +7090,33 @@
           </a:p>
         </p:txBody>
       </p:sp>
+      <p:pic>
+        <p:nvPicPr>
+          <p:cNvPr id="3" name="Picture 2" descr="college_logo.png"/>
+          <p:cNvPicPr>
+            <a:picLocks noChangeAspect="1"/>
+          </p:cNvPicPr>
+          <p:nvPr/>
+        </p:nvPicPr>
+        <p:blipFill>
+          <a:blip r:embed="rId2"/>
+          <a:stretch>
+            <a:fillRect/>
+          </a:stretch>
+        </p:blipFill>
+        <p:spPr>
+          <a:xfrm>
+            <a:off x="8412480" y="274320"/>
+            <a:ext cx="3108960" cy="685800"/>
+          </a:xfrm>
+          <a:prstGeom prst="rect">
+            <a:avLst/>
+          </a:prstGeom>
+        </p:spPr>
+      </p:pic>
       <p:sp>
         <p:nvSpPr>
-          <p:cNvPr id="3" name="TextBox 2"/>
+          <p:cNvPr id="4" name="TextBox 3"/>
           <p:cNvSpPr txBox="1"/>
           <p:nvPr/>
         </p:nvSpPr>
@@ -7034,7 +7235,7 @@
       </p:sp>
       <p:sp>
         <p:nvSpPr>
-          <p:cNvPr id="4" name="Rectangle 3"/>
+          <p:cNvPr id="5" name="Rectangle 4"/>
           <p:cNvSpPr/>
           <p:nvPr/>
         </p:nvSpPr>
@@ -8693,8 +8894,8 @@
         </p:nvSpPr>
         <p:spPr>
           <a:xfrm>
-            <a:off x="685800" y="457200"/>
-            <a:ext cx="10817352" cy="731520"/>
+            <a:off x="685800" y="365760"/>
+            <a:ext cx="7772400" cy="731520"/>
           </a:xfrm>
           <a:prstGeom prst="rect">
             <a:avLst/>
@@ -8721,9 +8922,33 @@
           </a:p>
         </p:txBody>
       </p:sp>
+      <p:pic>
+        <p:nvPicPr>
+          <p:cNvPr id="3" name="Picture 2" descr="college_logo.png"/>
+          <p:cNvPicPr>
+            <a:picLocks noChangeAspect="1"/>
+          </p:cNvPicPr>
+          <p:nvPr/>
+        </p:nvPicPr>
+        <p:blipFill>
+          <a:blip r:embed="rId2"/>
+          <a:stretch>
+            <a:fillRect/>
+          </a:stretch>
+        </p:blipFill>
+        <p:spPr>
+          <a:xfrm>
+            <a:off x="8412480" y="274320"/>
+            <a:ext cx="3108960" cy="685800"/>
+          </a:xfrm>
+          <a:prstGeom prst="rect">
+            <a:avLst/>
+          </a:prstGeom>
+        </p:spPr>
+      </p:pic>
       <p:sp>
         <p:nvSpPr>
-          <p:cNvPr id="3" name="TextBox 2"/>
+          <p:cNvPr id="4" name="TextBox 3"/>
           <p:cNvSpPr txBox="1"/>
           <p:nvPr/>
         </p:nvSpPr>
@@ -8890,8 +9115,8 @@
         </p:nvSpPr>
         <p:spPr>
           <a:xfrm>
-            <a:off x="685800" y="457200"/>
-            <a:ext cx="10817352" cy="731520"/>
+            <a:off x="685800" y="365760"/>
+            <a:ext cx="7772400" cy="731520"/>
           </a:xfrm>
           <a:prstGeom prst="rect">
             <a:avLst/>
@@ -8918,9 +9143,33 @@
           </a:p>
         </p:txBody>
       </p:sp>
+      <p:pic>
+        <p:nvPicPr>
+          <p:cNvPr id="3" name="Picture 2" descr="college_logo.png"/>
+          <p:cNvPicPr>
+            <a:picLocks noChangeAspect="1"/>
+          </p:cNvPicPr>
+          <p:nvPr/>
+        </p:nvPicPr>
+        <p:blipFill>
+          <a:blip r:embed="rId2"/>
+          <a:stretch>
+            <a:fillRect/>
+          </a:stretch>
+        </p:blipFill>
+        <p:spPr>
+          <a:xfrm>
+            <a:off x="8412480" y="274320"/>
+            <a:ext cx="3108960" cy="685800"/>
+          </a:xfrm>
+          <a:prstGeom prst="rect">
+            <a:avLst/>
+          </a:prstGeom>
+        </p:spPr>
+      </p:pic>
       <p:sp>
         <p:nvSpPr>
-          <p:cNvPr id="3" name="TextBox 2"/>
+          <p:cNvPr id="4" name="TextBox 3"/>
           <p:cNvSpPr txBox="1"/>
           <p:nvPr/>
         </p:nvSpPr>
@@ -9007,14 +9256,14 @@
       </p:sp>
       <p:pic>
         <p:nvPicPr>
-          <p:cNvPr id="4" name="Picture 3" descr="diff_highlights.png"/>
+          <p:cNvPr id="5" name="Picture 4" descr="diff_highlights.png"/>
           <p:cNvPicPr>
             <a:picLocks noChangeAspect="1"/>
           </p:cNvPicPr>
           <p:nvPr/>
         </p:nvPicPr>
         <p:blipFill>
-          <a:blip r:embed="rId2"/>
+          <a:blip r:embed="rId3"/>
           <a:stretch>
             <a:fillRect/>
           </a:stretch>
@@ -9063,8 +9312,8 @@
         </p:nvSpPr>
         <p:spPr>
           <a:xfrm>
-            <a:off x="685800" y="457200"/>
-            <a:ext cx="10817352" cy="731520"/>
+            <a:off x="685800" y="365760"/>
+            <a:ext cx="7772400" cy="731520"/>
           </a:xfrm>
           <a:prstGeom prst="rect">
             <a:avLst/>
@@ -9091,9 +9340,33 @@
           </a:p>
         </p:txBody>
       </p:sp>
+      <p:pic>
+        <p:nvPicPr>
+          <p:cNvPr id="3" name="Picture 2" descr="college_logo.png"/>
+          <p:cNvPicPr>
+            <a:picLocks noChangeAspect="1"/>
+          </p:cNvPicPr>
+          <p:nvPr/>
+        </p:nvPicPr>
+        <p:blipFill>
+          <a:blip r:embed="rId2"/>
+          <a:stretch>
+            <a:fillRect/>
+          </a:stretch>
+        </p:blipFill>
+        <p:spPr>
+          <a:xfrm>
+            <a:off x="8412480" y="274320"/>
+            <a:ext cx="3108960" cy="685800"/>
+          </a:xfrm>
+          <a:prstGeom prst="rect">
+            <a:avLst/>
+          </a:prstGeom>
+        </p:spPr>
+      </p:pic>
       <p:sp>
         <p:nvSpPr>
-          <p:cNvPr id="3" name="TextBox 2"/>
+          <p:cNvPr id="4" name="TextBox 3"/>
           <p:cNvSpPr txBox="1"/>
           <p:nvPr/>
         </p:nvSpPr>
@@ -9180,14 +9453,14 @@
       </p:sp>
       <p:pic>
         <p:nvPicPr>
-          <p:cNvPr id="4" name="Picture 3" descr="ui_sandbox.png"/>
+          <p:cNvPr id="5" name="Picture 4" descr="ui_sandbox.png"/>
           <p:cNvPicPr>
             <a:picLocks noChangeAspect="1"/>
           </p:cNvPicPr>
           <p:nvPr/>
         </p:nvPicPr>
         <p:blipFill>
-          <a:blip r:embed="rId2"/>
+          <a:blip r:embed="rId3"/>
           <a:stretch>
             <a:fillRect/>
           </a:stretch>
@@ -9236,8 +9509,8 @@
         </p:nvSpPr>
         <p:spPr>
           <a:xfrm>
-            <a:off x="685800" y="457200"/>
-            <a:ext cx="10817352" cy="731520"/>
+            <a:off x="685800" y="365760"/>
+            <a:ext cx="7772400" cy="731520"/>
           </a:xfrm>
           <a:prstGeom prst="rect">
             <a:avLst/>
@@ -9264,9 +9537,33 @@
           </a:p>
         </p:txBody>
       </p:sp>
+      <p:pic>
+        <p:nvPicPr>
+          <p:cNvPr id="3" name="Picture 2" descr="college_logo.png"/>
+          <p:cNvPicPr>
+            <a:picLocks noChangeAspect="1"/>
+          </p:cNvPicPr>
+          <p:nvPr/>
+        </p:nvPicPr>
+        <p:blipFill>
+          <a:blip r:embed="rId2"/>
+          <a:stretch>
+            <a:fillRect/>
+          </a:stretch>
+        </p:blipFill>
+        <p:spPr>
+          <a:xfrm>
+            <a:off x="8412480" y="274320"/>
+            <a:ext cx="3108960" cy="685800"/>
+          </a:xfrm>
+          <a:prstGeom prst="rect">
+            <a:avLst/>
+          </a:prstGeom>
+        </p:spPr>
+      </p:pic>
       <p:sp>
         <p:nvSpPr>
-          <p:cNvPr id="3" name="TextBox 2"/>
+          <p:cNvPr id="4" name="TextBox 3"/>
           <p:cNvSpPr txBox="1"/>
           <p:nvPr/>
         </p:nvSpPr>
@@ -9369,7 +9666,7 @@
       </p:sp>
       <p:sp>
         <p:nvSpPr>
-          <p:cNvPr id="4" name="Rectangle 3"/>
+          <p:cNvPr id="5" name="Rectangle 4"/>
           <p:cNvSpPr/>
           <p:nvPr/>
         </p:nvSpPr>
@@ -10302,8 +10599,8 @@
         </p:nvSpPr>
         <p:spPr>
           <a:xfrm>
-            <a:off x="685800" y="457200"/>
-            <a:ext cx="10817352" cy="731520"/>
+            <a:off x="685800" y="365760"/>
+            <a:ext cx="7772400" cy="731520"/>
           </a:xfrm>
           <a:prstGeom prst="rect">
             <a:avLst/>
@@ -10330,9 +10627,33 @@
           </a:p>
         </p:txBody>
       </p:sp>
+      <p:pic>
+        <p:nvPicPr>
+          <p:cNvPr id="3" name="Picture 2" descr="college_logo.png"/>
+          <p:cNvPicPr>
+            <a:picLocks noChangeAspect="1"/>
+          </p:cNvPicPr>
+          <p:nvPr/>
+        </p:nvPicPr>
+        <p:blipFill>
+          <a:blip r:embed="rId2"/>
+          <a:stretch>
+            <a:fillRect/>
+          </a:stretch>
+        </p:blipFill>
+        <p:spPr>
+          <a:xfrm>
+            <a:off x="8412480" y="274320"/>
+            <a:ext cx="3108960" cy="685800"/>
+          </a:xfrm>
+          <a:prstGeom prst="rect">
+            <a:avLst/>
+          </a:prstGeom>
+        </p:spPr>
+      </p:pic>
       <p:sp>
         <p:nvSpPr>
-          <p:cNvPr id="3" name="TextBox 2"/>
+          <p:cNvPr id="4" name="TextBox 3"/>
           <p:cNvSpPr txBox="1"/>
           <p:nvPr/>
         </p:nvSpPr>
@@ -10435,14 +10756,14 @@
       </p:sp>
       <p:pic>
         <p:nvPicPr>
-          <p:cNvPr id="4" name="Picture 3" descr="ui_sandbox.png"/>
+          <p:cNvPr id="5" name="Picture 4" descr="ui_sandbox.png"/>
           <p:cNvPicPr>
             <a:picLocks noChangeAspect="1"/>
           </p:cNvPicPr>
           <p:nvPr/>
         </p:nvPicPr>
         <p:blipFill>
-          <a:blip r:embed="rId2"/>
+          <a:blip r:embed="rId3"/>
           <a:stretch>
             <a:fillRect/>
           </a:stretch>
@@ -10491,8 +10812,8 @@
         </p:nvSpPr>
         <p:spPr>
           <a:xfrm>
-            <a:off x="685800" y="457200"/>
-            <a:ext cx="10817352" cy="731520"/>
+            <a:off x="685800" y="365760"/>
+            <a:ext cx="7772400" cy="731520"/>
           </a:xfrm>
           <a:prstGeom prst="rect">
             <a:avLst/>
@@ -10519,9 +10840,33 @@
           </a:p>
         </p:txBody>
       </p:sp>
+      <p:pic>
+        <p:nvPicPr>
+          <p:cNvPr id="3" name="Picture 2" descr="college_logo.png"/>
+          <p:cNvPicPr>
+            <a:picLocks noChangeAspect="1"/>
+          </p:cNvPicPr>
+          <p:nvPr/>
+        </p:nvPicPr>
+        <p:blipFill>
+          <a:blip r:embed="rId2"/>
+          <a:stretch>
+            <a:fillRect/>
+          </a:stretch>
+        </p:blipFill>
+        <p:spPr>
+          <a:xfrm>
+            <a:off x="8412480" y="274320"/>
+            <a:ext cx="3108960" cy="685800"/>
+          </a:xfrm>
+          <a:prstGeom prst="rect">
+            <a:avLst/>
+          </a:prstGeom>
+        </p:spPr>
+      </p:pic>
       <p:sp>
         <p:nvSpPr>
-          <p:cNvPr id="3" name="TextBox 2"/>
+          <p:cNvPr id="4" name="TextBox 3"/>
           <p:cNvSpPr txBox="1"/>
           <p:nvPr/>
         </p:nvSpPr>
@@ -10624,7 +10969,7 @@
       </p:sp>
       <p:sp>
         <p:nvSpPr>
-          <p:cNvPr id="4" name="Rectangle 3"/>
+          <p:cNvPr id="5" name="Rectangle 4"/>
           <p:cNvSpPr/>
           <p:nvPr/>
         </p:nvSpPr>
@@ -12338,8 +12683,8 @@
         </p:nvSpPr>
         <p:spPr>
           <a:xfrm>
-            <a:off x="685800" y="457200"/>
-            <a:ext cx="10817352" cy="731520"/>
+            <a:off x="685800" y="365760"/>
+            <a:ext cx="7772400" cy="731520"/>
           </a:xfrm>
           <a:prstGeom prst="rect">
             <a:avLst/>
@@ -12366,9 +12711,33 @@
           </a:p>
         </p:txBody>
       </p:sp>
+      <p:pic>
+        <p:nvPicPr>
+          <p:cNvPr id="3" name="Picture 2" descr="college_logo.png"/>
+          <p:cNvPicPr>
+            <a:picLocks noChangeAspect="1"/>
+          </p:cNvPicPr>
+          <p:nvPr/>
+        </p:nvPicPr>
+        <p:blipFill>
+          <a:blip r:embed="rId2"/>
+          <a:stretch>
+            <a:fillRect/>
+          </a:stretch>
+        </p:blipFill>
+        <p:spPr>
+          <a:xfrm>
+            <a:off x="8412480" y="274320"/>
+            <a:ext cx="3108960" cy="685800"/>
+          </a:xfrm>
+          <a:prstGeom prst="rect">
+            <a:avLst/>
+          </a:prstGeom>
+        </p:spPr>
+      </p:pic>
       <p:sp>
         <p:nvSpPr>
-          <p:cNvPr id="3" name="TextBox 2"/>
+          <p:cNvPr id="4" name="TextBox 3"/>
           <p:cNvSpPr txBox="1"/>
           <p:nvPr/>
         </p:nvSpPr>
@@ -12455,14 +12824,14 @@
       </p:sp>
       <p:pic>
         <p:nvPicPr>
-          <p:cNvPr id="4" name="Picture 3" descr="scanned_notes.jpg"/>
+          <p:cNvPr id="5" name="Picture 4" descr="scanned_notes.jpg"/>
           <p:cNvPicPr>
             <a:picLocks noChangeAspect="1"/>
           </p:cNvPicPr>
           <p:nvPr/>
         </p:nvPicPr>
         <p:blipFill>
-          <a:blip r:embed="rId2"/>
+          <a:blip r:embed="rId3"/>
           <a:stretch>
             <a:fillRect/>
           </a:stretch>
@@ -12511,8 +12880,8 @@
         </p:nvSpPr>
         <p:spPr>
           <a:xfrm>
-            <a:off x="685800" y="457200"/>
-            <a:ext cx="10817352" cy="731520"/>
+            <a:off x="685800" y="365760"/>
+            <a:ext cx="7772400" cy="731520"/>
           </a:xfrm>
           <a:prstGeom prst="rect">
             <a:avLst/>
@@ -12539,9 +12908,33 @@
           </a:p>
         </p:txBody>
       </p:sp>
+      <p:pic>
+        <p:nvPicPr>
+          <p:cNvPr id="3" name="Picture 2" descr="college_logo.png"/>
+          <p:cNvPicPr>
+            <a:picLocks noChangeAspect="1"/>
+          </p:cNvPicPr>
+          <p:nvPr/>
+        </p:nvPicPr>
+        <p:blipFill>
+          <a:blip r:embed="rId2"/>
+          <a:stretch>
+            <a:fillRect/>
+          </a:stretch>
+        </p:blipFill>
+        <p:spPr>
+          <a:xfrm>
+            <a:off x="8412480" y="274320"/>
+            <a:ext cx="3108960" cy="685800"/>
+          </a:xfrm>
+          <a:prstGeom prst="rect">
+            <a:avLst/>
+          </a:prstGeom>
+        </p:spPr>
+      </p:pic>
       <p:sp>
         <p:nvSpPr>
-          <p:cNvPr id="3" name="TextBox 2"/>
+          <p:cNvPr id="4" name="TextBox 3"/>
           <p:cNvSpPr txBox="1"/>
           <p:nvPr/>
         </p:nvSpPr>
@@ -12644,14 +13037,14 @@
       </p:sp>
       <p:pic>
         <p:nvPicPr>
-          <p:cNvPr id="4" name="Picture 3" descr="ui_empty.png"/>
+          <p:cNvPr id="5" name="Picture 4" descr="ui_empty.png"/>
           <p:cNvPicPr>
             <a:picLocks noChangeAspect="1"/>
           </p:cNvPicPr>
           <p:nvPr/>
         </p:nvPicPr>
         <p:blipFill>
-          <a:blip r:embed="rId2"/>
+          <a:blip r:embed="rId3"/>
           <a:stretch>
             <a:fillRect/>
           </a:stretch>
@@ -12700,8 +13093,8 @@
         </p:nvSpPr>
         <p:spPr>
           <a:xfrm>
-            <a:off x="685800" y="457200"/>
-            <a:ext cx="10817352" cy="731520"/>
+            <a:off x="685800" y="365760"/>
+            <a:ext cx="7772400" cy="731520"/>
           </a:xfrm>
           <a:prstGeom prst="rect">
             <a:avLst/>
@@ -12728,9 +13121,33 @@
           </a:p>
         </p:txBody>
       </p:sp>
+      <p:pic>
+        <p:nvPicPr>
+          <p:cNvPr id="3" name="Picture 2" descr="college_logo.png"/>
+          <p:cNvPicPr>
+            <a:picLocks noChangeAspect="1"/>
+          </p:cNvPicPr>
+          <p:nvPr/>
+        </p:nvPicPr>
+        <p:blipFill>
+          <a:blip r:embed="rId2"/>
+          <a:stretch>
+            <a:fillRect/>
+          </a:stretch>
+        </p:blipFill>
+        <p:spPr>
+          <a:xfrm>
+            <a:off x="8412480" y="274320"/>
+            <a:ext cx="3108960" cy="685800"/>
+          </a:xfrm>
+          <a:prstGeom prst="rect">
+            <a:avLst/>
+          </a:prstGeom>
+        </p:spPr>
+      </p:pic>
       <p:sp>
         <p:nvSpPr>
-          <p:cNvPr id="3" name="TextBox 2"/>
+          <p:cNvPr id="4" name="TextBox 3"/>
           <p:cNvSpPr txBox="1"/>
           <p:nvPr/>
         </p:nvSpPr>
@@ -12897,8 +13314,8 @@
         </p:nvSpPr>
         <p:spPr>
           <a:xfrm>
-            <a:off x="685800" y="457200"/>
-            <a:ext cx="10817352" cy="731520"/>
+            <a:off x="685800" y="365760"/>
+            <a:ext cx="7772400" cy="731520"/>
           </a:xfrm>
           <a:prstGeom prst="rect">
             <a:avLst/>
@@ -12925,9 +13342,33 @@
           </a:p>
         </p:txBody>
       </p:sp>
+      <p:pic>
+        <p:nvPicPr>
+          <p:cNvPr id="3" name="Picture 2" descr="college_logo.png"/>
+          <p:cNvPicPr>
+            <a:picLocks noChangeAspect="1"/>
+          </p:cNvPicPr>
+          <p:nvPr/>
+        </p:nvPicPr>
+        <p:blipFill>
+          <a:blip r:embed="rId2"/>
+          <a:stretch>
+            <a:fillRect/>
+          </a:stretch>
+        </p:blipFill>
+        <p:spPr>
+          <a:xfrm>
+            <a:off x="8412480" y="274320"/>
+            <a:ext cx="3108960" cy="685800"/>
+          </a:xfrm>
+          <a:prstGeom prst="rect">
+            <a:avLst/>
+          </a:prstGeom>
+        </p:spPr>
+      </p:pic>
       <p:sp>
         <p:nvSpPr>
-          <p:cNvPr id="3" name="TextBox 2"/>
+          <p:cNvPr id="4" name="TextBox 3"/>
           <p:cNvSpPr txBox="1"/>
           <p:nvPr/>
         </p:nvSpPr>
@@ -13193,8 +13634,8 @@
         </p:nvSpPr>
         <p:spPr>
           <a:xfrm>
-            <a:off x="685800" y="457200"/>
-            <a:ext cx="10817352" cy="731520"/>
+            <a:off x="685800" y="365760"/>
+            <a:ext cx="7772400" cy="731520"/>
           </a:xfrm>
           <a:prstGeom prst="rect">
             <a:avLst/>
@@ -13221,9 +13662,33 @@
           </a:p>
         </p:txBody>
       </p:sp>
+      <p:pic>
+        <p:nvPicPr>
+          <p:cNvPr id="3" name="Picture 2" descr="college_logo.png"/>
+          <p:cNvPicPr>
+            <a:picLocks noChangeAspect="1"/>
+          </p:cNvPicPr>
+          <p:nvPr/>
+        </p:nvPicPr>
+        <p:blipFill>
+          <a:blip r:embed="rId2"/>
+          <a:stretch>
+            <a:fillRect/>
+          </a:stretch>
+        </p:blipFill>
+        <p:spPr>
+          <a:xfrm>
+            <a:off x="8412480" y="274320"/>
+            <a:ext cx="3108960" cy="685800"/>
+          </a:xfrm>
+          <a:prstGeom prst="rect">
+            <a:avLst/>
+          </a:prstGeom>
+        </p:spPr>
+      </p:pic>
       <p:sp>
         <p:nvSpPr>
-          <p:cNvPr id="3" name="TextBox 2"/>
+          <p:cNvPr id="4" name="TextBox 3"/>
           <p:cNvSpPr txBox="1"/>
           <p:nvPr/>
         </p:nvSpPr>
@@ -13342,8 +13807,8 @@
         </p:nvSpPr>
         <p:spPr>
           <a:xfrm>
-            <a:off x="685800" y="457200"/>
-            <a:ext cx="10817352" cy="731520"/>
+            <a:off x="685800" y="365760"/>
+            <a:ext cx="7772400" cy="731520"/>
           </a:xfrm>
           <a:prstGeom prst="rect">
             <a:avLst/>
@@ -13370,9 +13835,33 @@
           </a:p>
         </p:txBody>
       </p:sp>
+      <p:pic>
+        <p:nvPicPr>
+          <p:cNvPr id="3" name="Picture 2" descr="college_logo.png"/>
+          <p:cNvPicPr>
+            <a:picLocks noChangeAspect="1"/>
+          </p:cNvPicPr>
+          <p:nvPr/>
+        </p:nvPicPr>
+        <p:blipFill>
+          <a:blip r:embed="rId2"/>
+          <a:stretch>
+            <a:fillRect/>
+          </a:stretch>
+        </p:blipFill>
+        <p:spPr>
+          <a:xfrm>
+            <a:off x="8412480" y="274320"/>
+            <a:ext cx="3108960" cy="685800"/>
+          </a:xfrm>
+          <a:prstGeom prst="rect">
+            <a:avLst/>
+          </a:prstGeom>
+        </p:spPr>
+      </p:pic>
       <p:sp>
         <p:nvSpPr>
-          <p:cNvPr id="3" name="TextBox 2"/>
+          <p:cNvPr id="4" name="TextBox 3"/>
           <p:cNvSpPr txBox="1"/>
           <p:nvPr/>
         </p:nvSpPr>
@@ -13507,8 +13996,8 @@
         </p:nvSpPr>
         <p:spPr>
           <a:xfrm>
-            <a:off x="685800" y="457200"/>
-            <a:ext cx="10817352" cy="731520"/>
+            <a:off x="685800" y="365760"/>
+            <a:ext cx="7772400" cy="731520"/>
           </a:xfrm>
           <a:prstGeom prst="rect">
             <a:avLst/>
@@ -13535,9 +14024,33 @@
           </a:p>
         </p:txBody>
       </p:sp>
+      <p:pic>
+        <p:nvPicPr>
+          <p:cNvPr id="3" name="Picture 2" descr="college_logo.png"/>
+          <p:cNvPicPr>
+            <a:picLocks noChangeAspect="1"/>
+          </p:cNvPicPr>
+          <p:nvPr/>
+        </p:nvPicPr>
+        <p:blipFill>
+          <a:blip r:embed="rId2"/>
+          <a:stretch>
+            <a:fillRect/>
+          </a:stretch>
+        </p:blipFill>
+        <p:spPr>
+          <a:xfrm>
+            <a:off x="8412480" y="274320"/>
+            <a:ext cx="3108960" cy="685800"/>
+          </a:xfrm>
+          <a:prstGeom prst="rect">
+            <a:avLst/>
+          </a:prstGeom>
+        </p:spPr>
+      </p:pic>
       <p:sp>
         <p:nvSpPr>
-          <p:cNvPr id="3" name="TextBox 2"/>
+          <p:cNvPr id="4" name="TextBox 3"/>
           <p:cNvSpPr txBox="1"/>
           <p:nvPr/>
         </p:nvSpPr>
@@ -13656,8 +14169,8 @@
         </p:nvSpPr>
         <p:spPr>
           <a:xfrm>
-            <a:off x="685800" y="457200"/>
-            <a:ext cx="10817352" cy="731520"/>
+            <a:off x="685800" y="365760"/>
+            <a:ext cx="7772400" cy="731520"/>
           </a:xfrm>
           <a:prstGeom prst="rect">
             <a:avLst/>
@@ -13684,9 +14197,33 @@
           </a:p>
         </p:txBody>
       </p:sp>
+      <p:pic>
+        <p:nvPicPr>
+          <p:cNvPr id="3" name="Picture 2" descr="college_logo.png"/>
+          <p:cNvPicPr>
+            <a:picLocks noChangeAspect="1"/>
+          </p:cNvPicPr>
+          <p:nvPr/>
+        </p:nvPicPr>
+        <p:blipFill>
+          <a:blip r:embed="rId2"/>
+          <a:stretch>
+            <a:fillRect/>
+          </a:stretch>
+        </p:blipFill>
+        <p:spPr>
+          <a:xfrm>
+            <a:off x="8412480" y="274320"/>
+            <a:ext cx="3108960" cy="685800"/>
+          </a:xfrm>
+          <a:prstGeom prst="rect">
+            <a:avLst/>
+          </a:prstGeom>
+        </p:spPr>
+      </p:pic>
       <p:sp>
         <p:nvSpPr>
-          <p:cNvPr id="3" name="TextBox 2"/>
+          <p:cNvPr id="4" name="TextBox 3"/>
           <p:cNvSpPr txBox="1"/>
           <p:nvPr/>
         </p:nvSpPr>
@@ -13805,8 +14342,8 @@
         </p:nvSpPr>
         <p:spPr>
           <a:xfrm>
-            <a:off x="685800" y="457200"/>
-            <a:ext cx="10817352" cy="731520"/>
+            <a:off x="685800" y="365760"/>
+            <a:ext cx="7772400" cy="731520"/>
           </a:xfrm>
           <a:prstGeom prst="rect">
             <a:avLst/>
@@ -13833,9 +14370,33 @@
           </a:p>
         </p:txBody>
       </p:sp>
+      <p:pic>
+        <p:nvPicPr>
+          <p:cNvPr id="3" name="Picture 2" descr="college_logo.png"/>
+          <p:cNvPicPr>
+            <a:picLocks noChangeAspect="1"/>
+          </p:cNvPicPr>
+          <p:nvPr/>
+        </p:nvPicPr>
+        <p:blipFill>
+          <a:blip r:embed="rId2"/>
+          <a:stretch>
+            <a:fillRect/>
+          </a:stretch>
+        </p:blipFill>
+        <p:spPr>
+          <a:xfrm>
+            <a:off x="8412480" y="274320"/>
+            <a:ext cx="3108960" cy="685800"/>
+          </a:xfrm>
+          <a:prstGeom prst="rect">
+            <a:avLst/>
+          </a:prstGeom>
+        </p:spPr>
+      </p:pic>
       <p:sp>
         <p:nvSpPr>
-          <p:cNvPr id="3" name="TextBox 2"/>
+          <p:cNvPr id="4" name="TextBox 3"/>
           <p:cNvSpPr txBox="1"/>
           <p:nvPr/>
         </p:nvSpPr>
@@ -13954,8 +14515,8 @@
         </p:nvSpPr>
         <p:spPr>
           <a:xfrm>
-            <a:off x="685800" y="457200"/>
-            <a:ext cx="10817352" cy="731520"/>
+            <a:off x="685800" y="365760"/>
+            <a:ext cx="7772400" cy="731520"/>
           </a:xfrm>
           <a:prstGeom prst="rect">
             <a:avLst/>
@@ -13982,9 +14543,33 @@
           </a:p>
         </p:txBody>
       </p:sp>
+      <p:pic>
+        <p:nvPicPr>
+          <p:cNvPr id="3" name="Picture 2" descr="college_logo.png"/>
+          <p:cNvPicPr>
+            <a:picLocks noChangeAspect="1"/>
+          </p:cNvPicPr>
+          <p:nvPr/>
+        </p:nvPicPr>
+        <p:blipFill>
+          <a:blip r:embed="rId2"/>
+          <a:stretch>
+            <a:fillRect/>
+          </a:stretch>
+        </p:blipFill>
+        <p:spPr>
+          <a:xfrm>
+            <a:off x="8412480" y="274320"/>
+            <a:ext cx="3108960" cy="685800"/>
+          </a:xfrm>
+          <a:prstGeom prst="rect">
+            <a:avLst/>
+          </a:prstGeom>
+        </p:spPr>
+      </p:pic>
       <p:sp>
         <p:nvSpPr>
-          <p:cNvPr id="3" name="TextBox 2"/>
+          <p:cNvPr id="4" name="TextBox 3"/>
           <p:cNvSpPr txBox="1"/>
           <p:nvPr/>
         </p:nvSpPr>
@@ -14071,14 +14656,14 @@
       </p:sp>
       <p:pic>
         <p:nvPicPr>
-          <p:cNvPr id="4" name="Picture 3" descr="ui_sandbox.png"/>
+          <p:cNvPr id="5" name="Picture 4" descr="ui_sandbox.png"/>
           <p:cNvPicPr>
             <a:picLocks noChangeAspect="1"/>
           </p:cNvPicPr>
           <p:nvPr/>
         </p:nvPicPr>
         <p:blipFill>
-          <a:blip r:embed="rId2"/>
+          <a:blip r:embed="rId3"/>
           <a:stretch>
             <a:fillRect/>
           </a:stretch>

</xml_diff>